<commit_message>
docs: update slide decks — latest version
</commit_message>
<xml_diff>
--- a/ppt/AI_CHEMIST_Deck.pptx
+++ b/ppt/AI_CHEMIST_Deck.pptx
@@ -4,6 +4,9 @@
   <p:sldMasterIdLst>
     <p:sldMasterId id="2147483648" r:id="rId1"/>
   </p:sldMasterIdLst>
+  <p:notesMasterIdLst>
+    <p:notesMasterId r:id="rId11"/>
+  </p:notesMasterIdLst>
   <p:sldIdLst>
     <p:sldId id="256" r:id="rId2"/>
     <p:sldId id="257" r:id="rId3"/>
@@ -15,10 +18,7 @@
     <p:sldId id="263" r:id="rId9"/>
     <p:sldId id="264" r:id="rId10"/>
   </p:sldIdLst>
-  <p:notesMasterIdLst>
-    <p:notesMasterId r:id="rId11"/>
-  </p:notesMasterIdLst>
-  <p:sldSz cx="9144000" cy="5143500"/>
+  <p:sldSz cx="9144000" cy="5143500" type="screen16x9"/>
   <p:notesSz cx="5143500" cy="9144000"/>
   <p:defaultTextStyle>
     <a:lvl1pPr marL="0" algn="l" defTabSz="914400" rtl="0" eaLnBrk="1" latinLnBrk="0" hangingPunct="1">
@@ -112,6 +112,11 @@
       </a:defRPr>
     </a:lvl9pPr>
   </p:defaultTextStyle>
+  <p:extLst>
+    <p:ext uri="{EFAFB233-063F-42B5-8137-9DF3F51BA10A}">
+      <p15:sldGuideLst xmlns:p15="http://schemas.microsoft.com/office/powerpoint/2012/main"/>
+    </p:ext>
+  </p:extLst>
 </p:presentation>
 </file>
 
@@ -137,234 +142,10 @@
           <a:chExt cx="0" cy="0"/>
         </a:xfrm>
       </p:grpSpPr>
-      <p:sp>
-        <p:nvSpPr>
-          <p:cNvPr id="2" name="Header Placeholder 1"/>
-          <p:cNvSpPr>
-            <a:spLocks noGrp="1"/>
-          </p:cNvSpPr>
-          <p:nvPr>
-            <p:ph type="hdr" sz="quarter"/>
-          </p:nvPr>
-        </p:nvSpPr>
-        <p:spPr>
-          <a:xfrm>
-            <a:off x="0" y="0"/>
-            <a:ext cx="2971800" cy="458788"/>
-          </a:xfrm>
-          <a:prstGeom prst="rect">
-            <a:avLst/>
-          </a:prstGeom>
-        </p:spPr>
-        <p:txBody>
-          <a:bodyPr vert="horz" lIns="91440" tIns="45720" rIns="91440" bIns="45720" rtlCol="0"/>
-          <a:lstStyle>
-            <a:lvl1pPr algn="l">
-              <a:defRPr sz="1200"/>
-            </a:lvl1pPr>
-          </a:lstStyle>
-          <a:p>
-            <a:endParaRPr lang="en-US"/>
-          </a:p>
-        </p:txBody>
-      </p:sp>
-      <p:sp>
-        <p:nvSpPr>
-          <p:cNvPr id="3" name="Date Placeholder 2"/>
-          <p:cNvSpPr>
-            <a:spLocks noGrp="1"/>
-          </p:cNvSpPr>
-          <p:nvPr>
-            <p:ph type="dt" idx="1"/>
-          </p:nvPr>
-        </p:nvSpPr>
-        <p:spPr>
-          <a:xfrm>
-            <a:off x="3884613" y="0"/>
-            <a:ext cx="2971800" cy="458788"/>
-          </a:xfrm>
-          <a:prstGeom prst="rect">
-            <a:avLst/>
-          </a:prstGeom>
-        </p:spPr>
-        <p:txBody>
-          <a:bodyPr vert="horz" lIns="91440" tIns="45720" rIns="91440" bIns="45720" rtlCol="0"/>
-          <a:lstStyle>
-            <a:lvl1pPr algn="r">
-              <a:defRPr sz="1200"/>
-            </a:lvl1pPr>
-          </a:lstStyle>
-          <a:p>
-            <a:fld id="{5282F153-3F37-0F45-9E97-73ACFA13230C}" type="datetimeFigureOut">
-              <a:rPr lang="en-US"/>
-              <a:t>7/23/19</a:t>
-            </a:fld>
-            <a:endParaRPr lang="en-US"/>
-          </a:p>
-        </p:txBody>
-      </p:sp>
-      <p:sp>
-        <p:nvSpPr>
-          <p:cNvPr id="4" name="Slide Image Placeholder 3"/>
-          <p:cNvSpPr>
-            <a:spLocks noGrp="1" noRot="1" noChangeAspect="1"/>
-          </p:cNvSpPr>
-          <p:nvPr>
-            <p:ph type="sldImg" idx="2"/>
-          </p:nvPr>
-        </p:nvSpPr>
-        <p:spPr>
-          <a:xfrm>
-            <a:off x="685800" y="1143000"/>
-            <a:ext cx="5486400" cy="3086100"/>
-          </a:xfrm>
-          <a:prstGeom prst="rect">
-            <a:avLst/>
-          </a:prstGeom>
-          <a:noFill/>
-          <a:ln w="12700">
-            <a:solidFill>
-              <a:prstClr val="black"/>
-            </a:solidFill>
-          </a:ln>
-        </p:spPr>
-        <p:txBody>
-          <a:bodyPr vert="horz" lIns="91440" tIns="45720" rIns="91440" bIns="45720" rtlCol="0" anchor="ctr"/>
-          <a:lstStyle/>
-          <a:p>
-            <a:endParaRPr lang="en-US"/>
-          </a:p>
-        </p:txBody>
-      </p:sp>
-      <p:sp>
-        <p:nvSpPr>
-          <p:cNvPr id="5" name="Notes Placeholder 4"/>
-          <p:cNvSpPr>
-            <a:spLocks noGrp="1"/>
-          </p:cNvSpPr>
-          <p:nvPr>
-            <p:ph type="body" sz="quarter" idx="3"/>
-          </p:nvPr>
-        </p:nvSpPr>
-        <p:spPr>
-          <a:xfrm>
-            <a:off x="685800" y="4400550"/>
-            <a:ext cx="5486400" cy="3600450"/>
-          </a:xfrm>
-          <a:prstGeom prst="rect">
-            <a:avLst/>
-          </a:prstGeom>
-        </p:spPr>
-        <p:txBody>
-          <a:bodyPr vert="horz" lIns="91440" tIns="45720" rIns="91440" bIns="45720" rtlCol="0"/>
-          <a:lstStyle/>
-          <a:p>
-            <a:pPr lvl="0"/>
-            <a:r>
-              <a:rPr lang="en-US"/>
-              <a:t>Click to edit Master text styles</a:t>
-            </a:r>
-          </a:p>
-          <a:p>
-            <a:pPr lvl="1"/>
-            <a:r>
-              <a:rPr lang="en-US"/>
-              <a:t>Second level</a:t>
-            </a:r>
-          </a:p>
-          <a:p>
-            <a:pPr lvl="2"/>
-            <a:r>
-              <a:rPr lang="en-US"/>
-              <a:t>Third level</a:t>
-            </a:r>
-          </a:p>
-          <a:p>
-            <a:pPr lvl="3"/>
-            <a:r>
-              <a:rPr lang="en-US"/>
-              <a:t>Fourth level</a:t>
-            </a:r>
-          </a:p>
-          <a:p>
-            <a:pPr lvl="4"/>
-            <a:r>
-              <a:rPr lang="en-US"/>
-              <a:t>Fifth level</a:t>
-            </a:r>
-          </a:p>
-        </p:txBody>
-      </p:sp>
-      <p:sp>
-        <p:nvSpPr>
-          <p:cNvPr id="6" name="Footer Placeholder 5"/>
-          <p:cNvSpPr>
-            <a:spLocks noGrp="1"/>
-          </p:cNvSpPr>
-          <p:nvPr>
-            <p:ph type="ftr" sz="quarter" idx="4"/>
-          </p:nvPr>
-        </p:nvSpPr>
-        <p:spPr>
-          <a:xfrm>
-            <a:off x="0" y="8685213"/>
-            <a:ext cx="2971800" cy="458787"/>
-          </a:xfrm>
-          <a:prstGeom prst="rect">
-            <a:avLst/>
-          </a:prstGeom>
-        </p:spPr>
-        <p:txBody>
-          <a:bodyPr vert="horz" lIns="91440" tIns="45720" rIns="91440" bIns="45720" rtlCol="0" anchor="b"/>
-          <a:lstStyle>
-            <a:lvl1pPr algn="l">
-              <a:defRPr sz="1200"/>
-            </a:lvl1pPr>
-          </a:lstStyle>
-          <a:p>
-            <a:endParaRPr lang="en-US"/>
-          </a:p>
-        </p:txBody>
-      </p:sp>
-      <p:sp>
-        <p:nvSpPr>
-          <p:cNvPr id="7" name="Slide Number Placeholder 6"/>
-          <p:cNvSpPr>
-            <a:spLocks noGrp="1"/>
-          </p:cNvSpPr>
-          <p:nvPr>
-            <p:ph type="sldNum" sz="quarter" idx="5"/>
-          </p:nvPr>
-        </p:nvSpPr>
-        <p:spPr>
-          <a:xfrm>
-            <a:off x="3884613" y="8685213"/>
-            <a:ext cx="2971800" cy="458787"/>
-          </a:xfrm>
-          <a:prstGeom prst="rect">
-            <a:avLst/>
-          </a:prstGeom>
-        </p:spPr>
-        <p:txBody>
-          <a:bodyPr vert="horz" lIns="91440" tIns="45720" rIns="91440" bIns="45720" rtlCol="0" anchor="b"/>
-          <a:lstStyle>
-            <a:lvl1pPr algn="r">
-              <a:defRPr sz="1200"/>
-            </a:lvl1pPr>
-          </a:lstStyle>
-          <a:p>
-            <a:fld id="{CE5E9CC1-C706-0F49-92D6-E571CC5EEA8F}" type="slidenum">
-              <a:rPr lang="en-US"/>
-              <a:t>‹#›</a:t>
-            </a:fld>
-            <a:endParaRPr lang="en-US"/>
-          </a:p>
-        </p:txBody>
-      </p:sp>
     </p:spTree>
     <p:extLst>
       <p:ext uri="{BB962C8B-B14F-4D97-AF65-F5344CB8AC3E}">
-        <p14:creationId xmlns:p14="http://schemas.microsoft.com/office/powerpoint/2010/main" val="1024086991"/>
+        <p14:creationId xmlns:p14="http://schemas.microsoft.com/office/powerpoint/2010/main" val="3162822199"/>
       </p:ext>
     </p:extLst>
   </p:cSld>
@@ -508,10 +289,6 @@
           <a:bodyPr/>
           <a:lstStyle/>
           <a:p>
-            <a:r>
-              <a:rPr lang="en-US" dirty="0"/>
-              <a:t/>
-            </a:r>
             <a:endParaRPr lang="en-US" dirty="0"/>
           </a:p>
         </p:txBody>
@@ -596,10 +373,6 @@
           <a:bodyPr/>
           <a:lstStyle/>
           <a:p>
-            <a:r>
-              <a:rPr lang="en-US" dirty="0"/>
-              <a:t/>
-            </a:r>
             <a:endParaRPr lang="en-US" dirty="0"/>
           </a:p>
         </p:txBody>
@@ -684,10 +457,6 @@
           <a:bodyPr/>
           <a:lstStyle/>
           <a:p>
-            <a:r>
-              <a:rPr lang="en-US" dirty="0"/>
-              <a:t/>
-            </a:r>
             <a:endParaRPr lang="en-US" dirty="0"/>
           </a:p>
         </p:txBody>
@@ -772,10 +541,6 @@
           <a:bodyPr/>
           <a:lstStyle/>
           <a:p>
-            <a:r>
-              <a:rPr lang="en-US" dirty="0"/>
-              <a:t/>
-            </a:r>
             <a:endParaRPr lang="en-US" dirty="0"/>
           </a:p>
         </p:txBody>
@@ -860,10 +625,6 @@
           <a:bodyPr/>
           <a:lstStyle/>
           <a:p>
-            <a:r>
-              <a:rPr lang="en-US" dirty="0"/>
-              <a:t/>
-            </a:r>
             <a:endParaRPr lang="en-US" dirty="0"/>
           </a:p>
         </p:txBody>
@@ -948,10 +709,6 @@
           <a:bodyPr/>
           <a:lstStyle/>
           <a:p>
-            <a:r>
-              <a:rPr lang="en-US" dirty="0"/>
-              <a:t/>
-            </a:r>
             <a:endParaRPr lang="en-US" dirty="0"/>
           </a:p>
         </p:txBody>
@@ -1036,10 +793,6 @@
           <a:bodyPr/>
           <a:lstStyle/>
           <a:p>
-            <a:r>
-              <a:rPr lang="en-US" dirty="0"/>
-              <a:t/>
-            </a:r>
             <a:endParaRPr lang="en-US" dirty="0"/>
           </a:p>
         </p:txBody>
@@ -1124,10 +877,6 @@
           <a:bodyPr/>
           <a:lstStyle/>
           <a:p>
-            <a:r>
-              <a:rPr lang="en-US" dirty="0"/>
-              <a:t/>
-            </a:r>
             <a:endParaRPr lang="en-US" dirty="0"/>
           </a:p>
         </p:txBody>
@@ -1212,10 +961,6 @@
           <a:bodyPr/>
           <a:lstStyle/>
           <a:p>
-            <a:r>
-              <a:rPr lang="en-US" dirty="0"/>
-              <a:t/>
-            </a:r>
             <a:endParaRPr lang="en-US" dirty="0"/>
           </a:p>
         </p:txBody>
@@ -1289,6 +1034,11 @@
 <file path=ppt/slideMasters/slideMaster1.xml><?xml version="1.0" encoding="utf-8"?>
 <p:sldMaster xmlns:a="http://schemas.openxmlformats.org/drawingml/2006/main" xmlns:r="http://schemas.openxmlformats.org/officeDocument/2006/relationships" xmlns:p="http://schemas.openxmlformats.org/presentationml/2006/main">
   <p:cSld>
+    <p:bg>
+      <p:bgRef idx="1001">
+        <a:schemeClr val="bg1"/>
+      </p:bgRef>
+    </p:bg>
     <p:spTree>
       <p:nvGrpSpPr>
         <p:cNvPr id="1" name=""/>
@@ -1571,6 +1321,7 @@
         <a:solidFill>
           <a:srgbClr val="0D1B2A"/>
         </a:solidFill>
+        <a:effectLst/>
       </p:bgPr>
     </p:bg>
     <p:spTree>
@@ -1606,6 +1357,13 @@
           </a:solidFill>
           <a:ln/>
         </p:spPr>
+        <p:txBody>
+          <a:bodyPr/>
+          <a:lstStyle/>
+          <a:p>
+            <a:endParaRPr lang="zh-CN" altLang="en-US"/>
+          </a:p>
+        </p:txBody>
       </p:sp>
       <p:sp>
         <p:nvSpPr>
@@ -1626,6 +1384,13 @@
           </a:solidFill>
           <a:ln/>
         </p:spPr>
+        <p:txBody>
+          <a:bodyPr/>
+          <a:lstStyle/>
+          <a:p>
+            <a:endParaRPr lang="zh-CN" altLang="en-US"/>
+          </a:p>
+        </p:txBody>
       </p:sp>
       <p:sp>
         <p:nvSpPr>
@@ -1646,6 +1411,13 @@
           </a:solidFill>
           <a:ln/>
         </p:spPr>
+        <p:txBody>
+          <a:bodyPr/>
+          <a:lstStyle/>
+          <a:p>
+            <a:endParaRPr lang="zh-CN" altLang="en-US"/>
+          </a:p>
+        </p:txBody>
       </p:sp>
       <p:sp>
         <p:nvSpPr>
@@ -1668,11 +1440,11 @@
           <a:bodyPr wrap="square" lIns="0" tIns="0" rIns="0" bIns="0" rtlCol="0" anchor="ctr"/>
           <a:lstStyle/>
           <a:p>
-            <a:pPr indent="0" marL="0">
-              <a:buNone/>
-            </a:pPr>
-            <a:r>
-              <a:rPr lang="en-US" sz="5400" b="1" spc="800" kern="0" dirty="0">
+            <a:pPr marL="0" indent="0">
+              <a:buNone/>
+            </a:pPr>
+            <a:r>
+              <a:rPr lang="en-US" sz="5400" b="1" kern="0" spc="800" dirty="0">
                 <a:solidFill>
                   <a:srgbClr val="E8E4DD"/>
                 </a:solidFill>
@@ -1708,6 +1480,13 @@
             <a:prstDash val="solid"/>
           </a:ln>
         </p:spPr>
+        <p:txBody>
+          <a:bodyPr/>
+          <a:lstStyle/>
+          <a:p>
+            <a:endParaRPr lang="zh-CN" altLang="en-US"/>
+          </a:p>
+        </p:txBody>
       </p:sp>
       <p:sp>
         <p:nvSpPr>
@@ -1730,7 +1509,7 @@
           <a:bodyPr wrap="square" lIns="0" tIns="0" rIns="0" bIns="0" rtlCol="0" anchor="ctr"/>
           <a:lstStyle/>
           <a:p>
-            <a:pPr indent="0" marL="0">
+            <a:pPr marL="0" indent="0">
               <a:buNone/>
             </a:pPr>
             <a:r>
@@ -1769,7 +1548,7 @@
           <a:bodyPr wrap="square" lIns="0" tIns="0" rIns="0" bIns="0" rtlCol="0" anchor="ctr"/>
           <a:lstStyle/>
           <a:p>
-            <a:pPr indent="0" marL="0">
+            <a:pPr marL="0" indent="0">
               <a:lnSpc>
                 <a:spcPct val="170000"/>
               </a:lnSpc>
@@ -1789,7 +1568,7 @@
             <a:endParaRPr lang="en-US" sz="1300" dirty="0"/>
           </a:p>
           <a:p>
-            <a:pPr indent="0" marL="0">
+            <a:pPr marL="0" indent="0">
               <a:lnSpc>
                 <a:spcPct val="170000"/>
               </a:lnSpc>
@@ -1831,11 +1610,11 @@
           <a:bodyPr wrap="square" rtlCol="0" anchor="ctr"/>
           <a:lstStyle/>
           <a:p>
-            <a:pPr indent="0" marL="0">
-              <a:buNone/>
-            </a:pPr>
-            <a:r>
-              <a:rPr lang="en-US" sz="800" spc="200" kern="0" dirty="0">
+            <a:pPr marL="0" indent="0">
+              <a:buNone/>
+            </a:pPr>
+            <a:r>
+              <a:rPr lang="en-US" sz="800" kern="0" spc="200" dirty="0">
                 <a:solidFill>
                   <a:srgbClr val="8A95A5"/>
                 </a:solidFill>
@@ -1870,11 +1649,11 @@
           <a:bodyPr wrap="square" rtlCol="0" anchor="ctr"/>
           <a:lstStyle/>
           <a:p>
-            <a:pPr algn="r" indent="0" marL="0">
-              <a:buNone/>
-            </a:pPr>
-            <a:r>
-              <a:rPr lang="en-US" sz="900" spc="300" kern="0" dirty="0">
+            <a:pPr marL="0" indent="0" algn="r">
+              <a:buNone/>
+            </a:pPr>
+            <a:r>
+              <a:rPr lang="en-US" sz="900" kern="0" spc="300" dirty="0">
                 <a:solidFill>
                   <a:srgbClr val="C9A96E"/>
                 </a:solidFill>
@@ -1910,6 +1689,13 @@
             <a:prstDash val="solid"/>
           </a:ln>
         </p:spPr>
+        <p:txBody>
+          <a:bodyPr/>
+          <a:lstStyle/>
+          <a:p>
+            <a:endParaRPr lang="zh-CN" altLang="en-US"/>
+          </a:p>
+        </p:txBody>
       </p:sp>
     </p:spTree>
   </p:cSld>
@@ -1927,6 +1713,7 @@
         <a:solidFill>
           <a:srgbClr val="0D1B2A"/>
         </a:solidFill>
+        <a:effectLst/>
       </p:bgPr>
     </p:bg>
     <p:spTree>
@@ -1964,7 +1751,7 @@
           <a:bodyPr wrap="square" lIns="0" tIns="0" rIns="0" bIns="0" rtlCol="0" anchor="ctr"/>
           <a:lstStyle/>
           <a:p>
-            <a:pPr indent="0" marL="0">
+            <a:pPr marL="0" indent="0">
               <a:buNone/>
             </a:pPr>
             <a:r>
@@ -2004,6 +1791,13 @@
             <a:prstDash val="solid"/>
           </a:ln>
         </p:spPr>
+        <p:txBody>
+          <a:bodyPr/>
+          <a:lstStyle/>
+          <a:p>
+            <a:endParaRPr lang="zh-CN" altLang="en-US"/>
+          </a:p>
+        </p:txBody>
       </p:sp>
       <p:sp>
         <p:nvSpPr>
@@ -2017,15 +1811,20 @@
             <a:ext cx="1828800" cy="2331720"/>
           </a:xfrm>
           <a:prstGeom prst="rect">
-            <a:avLst>
-              <a:gd name="adj" fmla="val 2500"/>
-            </a:avLst>
+            <a:avLst/>
           </a:prstGeom>
           <a:solidFill>
             <a:srgbClr val="152238"/>
           </a:solidFill>
           <a:ln/>
         </p:spPr>
+        <p:txBody>
+          <a:bodyPr/>
+          <a:lstStyle/>
+          <a:p>
+            <a:endParaRPr lang="zh-CN" altLang="en-US"/>
+          </a:p>
+        </p:txBody>
       </p:sp>
       <p:sp>
         <p:nvSpPr>
@@ -2046,6 +1845,13 @@
           </a:solidFill>
           <a:ln/>
         </p:spPr>
+        <p:txBody>
+          <a:bodyPr/>
+          <a:lstStyle/>
+          <a:p>
+            <a:endParaRPr lang="zh-CN" altLang="en-US"/>
+          </a:p>
+        </p:txBody>
       </p:sp>
       <p:sp>
         <p:nvSpPr>
@@ -2068,7 +1874,7 @@
           <a:bodyPr wrap="square" lIns="0" tIns="0" rIns="0" bIns="0" rtlCol="0" anchor="ctr"/>
           <a:lstStyle/>
           <a:p>
-            <a:pPr indent="0" marL="0">
+            <a:pPr marL="0" indent="0">
               <a:buNone/>
             </a:pPr>
             <a:r>
@@ -2107,7 +1913,7 @@
           <a:bodyPr wrap="square" lIns="0" tIns="0" rIns="0" bIns="0" rtlCol="0" anchor="ctr"/>
           <a:lstStyle/>
           <a:p>
-            <a:pPr indent="0" marL="0">
+            <a:pPr marL="0" indent="0">
               <a:buNone/>
             </a:pPr>
             <a:r>
@@ -2146,11 +1952,11 @@
           <a:bodyPr wrap="square" lIns="0" tIns="0" rIns="0" bIns="0" rtlCol="0" anchor="ctr"/>
           <a:lstStyle/>
           <a:p>
-            <a:pPr indent="0" marL="0">
-              <a:buNone/>
-            </a:pPr>
-            <a:r>
-              <a:rPr lang="en-US" sz="1000" spc="200" kern="0" dirty="0">
+            <a:pPr marL="0" indent="0">
+              <a:buNone/>
+            </a:pPr>
+            <a:r>
+              <a:rPr lang="en-US" sz="1000" kern="0" spc="200" dirty="0">
                 <a:solidFill>
                   <a:srgbClr val="C9A96E"/>
                 </a:solidFill>
@@ -2185,7 +1991,7 @@
           <a:bodyPr wrap="square" lIns="0" tIns="0" rIns="0" bIns="0" rtlCol="0" anchor="ctr"/>
           <a:lstStyle/>
           <a:p>
-            <a:pPr indent="0" marL="0">
+            <a:pPr marL="0" indent="0">
               <a:lnSpc>
                 <a:spcPct val="150000"/>
               </a:lnSpc>
@@ -2205,7 +2011,7 @@
             <a:endParaRPr lang="en-US" sz="950" dirty="0"/>
           </a:p>
           <a:p>
-            <a:pPr indent="0" marL="0">
+            <a:pPr marL="0" indent="0">
               <a:lnSpc>
                 <a:spcPct val="150000"/>
               </a:lnSpc>
@@ -2247,7 +2053,7 @@
           <a:bodyPr wrap="square" lIns="0" tIns="0" rIns="0" bIns="0" rtlCol="0" anchor="ctr"/>
           <a:lstStyle/>
           <a:p>
-            <a:pPr algn="ctr" indent="0" marL="0">
+            <a:pPr marL="0" indent="0" algn="ctr">
               <a:buNone/>
             </a:pPr>
             <a:r>
@@ -2274,15 +2080,20 @@
             <a:ext cx="1828800" cy="2331720"/>
           </a:xfrm>
           <a:prstGeom prst="rect">
-            <a:avLst>
-              <a:gd name="adj" fmla="val 2500"/>
-            </a:avLst>
+            <a:avLst/>
           </a:prstGeom>
           <a:solidFill>
             <a:srgbClr val="152238"/>
           </a:solidFill>
           <a:ln/>
         </p:spPr>
+        <p:txBody>
+          <a:bodyPr/>
+          <a:lstStyle/>
+          <a:p>
+            <a:endParaRPr lang="zh-CN" altLang="en-US"/>
+          </a:p>
+        </p:txBody>
       </p:sp>
       <p:sp>
         <p:nvSpPr>
@@ -2303,6 +2114,13 @@
           </a:solidFill>
           <a:ln/>
         </p:spPr>
+        <p:txBody>
+          <a:bodyPr/>
+          <a:lstStyle/>
+          <a:p>
+            <a:endParaRPr lang="zh-CN" altLang="en-US"/>
+          </a:p>
+        </p:txBody>
       </p:sp>
       <p:sp>
         <p:nvSpPr>
@@ -2325,7 +2143,7 @@
           <a:bodyPr wrap="square" lIns="0" tIns="0" rIns="0" bIns="0" rtlCol="0" anchor="ctr"/>
           <a:lstStyle/>
           <a:p>
-            <a:pPr indent="0" marL="0">
+            <a:pPr marL="0" indent="0">
               <a:buNone/>
             </a:pPr>
             <a:r>
@@ -2364,7 +2182,7 @@
           <a:bodyPr wrap="square" lIns="0" tIns="0" rIns="0" bIns="0" rtlCol="0" anchor="ctr"/>
           <a:lstStyle/>
           <a:p>
-            <a:pPr indent="0" marL="0">
+            <a:pPr marL="0" indent="0">
               <a:buNone/>
             </a:pPr>
             <a:r>
@@ -2403,11 +2221,11 @@
           <a:bodyPr wrap="square" lIns="0" tIns="0" rIns="0" bIns="0" rtlCol="0" anchor="ctr"/>
           <a:lstStyle/>
           <a:p>
-            <a:pPr indent="0" marL="0">
-              <a:buNone/>
-            </a:pPr>
-            <a:r>
-              <a:rPr lang="en-US" sz="1000" spc="200" kern="0" dirty="0">
+            <a:pPr marL="0" indent="0">
+              <a:buNone/>
+            </a:pPr>
+            <a:r>
+              <a:rPr lang="en-US" sz="1000" kern="0" spc="200" dirty="0">
                 <a:solidFill>
                   <a:srgbClr val="C9A96E"/>
                 </a:solidFill>
@@ -2442,7 +2260,7 @@
           <a:bodyPr wrap="square" lIns="0" tIns="0" rIns="0" bIns="0" rtlCol="0" anchor="ctr"/>
           <a:lstStyle/>
           <a:p>
-            <a:pPr indent="0" marL="0">
+            <a:pPr marL="0" indent="0">
               <a:lnSpc>
                 <a:spcPct val="150000"/>
               </a:lnSpc>
@@ -2462,7 +2280,7 @@
             <a:endParaRPr lang="en-US" sz="950" dirty="0"/>
           </a:p>
           <a:p>
-            <a:pPr indent="0" marL="0">
+            <a:pPr marL="0" indent="0">
               <a:lnSpc>
                 <a:spcPct val="150000"/>
               </a:lnSpc>
@@ -2504,7 +2322,7 @@
           <a:bodyPr wrap="square" lIns="0" tIns="0" rIns="0" bIns="0" rtlCol="0" anchor="ctr"/>
           <a:lstStyle/>
           <a:p>
-            <a:pPr algn="ctr" indent="0" marL="0">
+            <a:pPr marL="0" indent="0" algn="ctr">
               <a:buNone/>
             </a:pPr>
             <a:r>
@@ -2531,15 +2349,20 @@
             <a:ext cx="1828800" cy="2331720"/>
           </a:xfrm>
           <a:prstGeom prst="rect">
-            <a:avLst>
-              <a:gd name="adj" fmla="val 2500"/>
-            </a:avLst>
+            <a:avLst/>
           </a:prstGeom>
           <a:solidFill>
             <a:srgbClr val="152238"/>
           </a:solidFill>
           <a:ln/>
         </p:spPr>
+        <p:txBody>
+          <a:bodyPr/>
+          <a:lstStyle/>
+          <a:p>
+            <a:endParaRPr lang="zh-CN" altLang="en-US"/>
+          </a:p>
+        </p:txBody>
       </p:sp>
       <p:sp>
         <p:nvSpPr>
@@ -2560,6 +2383,13 @@
           </a:solidFill>
           <a:ln/>
         </p:spPr>
+        <p:txBody>
+          <a:bodyPr/>
+          <a:lstStyle/>
+          <a:p>
+            <a:endParaRPr lang="zh-CN" altLang="en-US"/>
+          </a:p>
+        </p:txBody>
       </p:sp>
       <p:sp>
         <p:nvSpPr>
@@ -2582,7 +2412,7 @@
           <a:bodyPr wrap="square" lIns="0" tIns="0" rIns="0" bIns="0" rtlCol="0" anchor="ctr"/>
           <a:lstStyle/>
           <a:p>
-            <a:pPr indent="0" marL="0">
+            <a:pPr marL="0" indent="0">
               <a:buNone/>
             </a:pPr>
             <a:r>
@@ -2621,7 +2451,7 @@
           <a:bodyPr wrap="square" lIns="0" tIns="0" rIns="0" bIns="0" rtlCol="0" anchor="ctr"/>
           <a:lstStyle/>
           <a:p>
-            <a:pPr indent="0" marL="0">
+            <a:pPr marL="0" indent="0">
               <a:buNone/>
             </a:pPr>
             <a:r>
@@ -2660,11 +2490,11 @@
           <a:bodyPr wrap="square" lIns="0" tIns="0" rIns="0" bIns="0" rtlCol="0" anchor="ctr"/>
           <a:lstStyle/>
           <a:p>
-            <a:pPr indent="0" marL="0">
-              <a:buNone/>
-            </a:pPr>
-            <a:r>
-              <a:rPr lang="en-US" sz="1000" spc="200" kern="0" dirty="0">
+            <a:pPr marL="0" indent="0">
+              <a:buNone/>
+            </a:pPr>
+            <a:r>
+              <a:rPr lang="en-US" sz="1000" kern="0" spc="200" dirty="0">
                 <a:solidFill>
                   <a:srgbClr val="C9A96E"/>
                 </a:solidFill>
@@ -2699,7 +2529,7 @@
           <a:bodyPr wrap="square" lIns="0" tIns="0" rIns="0" bIns="0" rtlCol="0" anchor="ctr"/>
           <a:lstStyle/>
           <a:p>
-            <a:pPr indent="0" marL="0">
+            <a:pPr marL="0" indent="0">
               <a:lnSpc>
                 <a:spcPct val="150000"/>
               </a:lnSpc>
@@ -2719,7 +2549,7 @@
             <a:endParaRPr lang="en-US" sz="950" dirty="0"/>
           </a:p>
           <a:p>
-            <a:pPr indent="0" marL="0">
+            <a:pPr marL="0" indent="0">
               <a:lnSpc>
                 <a:spcPct val="150000"/>
               </a:lnSpc>
@@ -2761,7 +2591,7 @@
           <a:bodyPr wrap="square" lIns="0" tIns="0" rIns="0" bIns="0" rtlCol="0" anchor="ctr"/>
           <a:lstStyle/>
           <a:p>
-            <a:pPr algn="ctr" indent="0" marL="0">
+            <a:pPr marL="0" indent="0" algn="ctr">
               <a:buNone/>
             </a:pPr>
             <a:r>
@@ -2788,15 +2618,20 @@
             <a:ext cx="1828800" cy="2331720"/>
           </a:xfrm>
           <a:prstGeom prst="rect">
-            <a:avLst>
-              <a:gd name="adj" fmla="val 2500"/>
-            </a:avLst>
+            <a:avLst/>
           </a:prstGeom>
           <a:solidFill>
             <a:srgbClr val="152238"/>
           </a:solidFill>
           <a:ln/>
         </p:spPr>
+        <p:txBody>
+          <a:bodyPr/>
+          <a:lstStyle/>
+          <a:p>
+            <a:endParaRPr lang="zh-CN" altLang="en-US"/>
+          </a:p>
+        </p:txBody>
       </p:sp>
       <p:sp>
         <p:nvSpPr>
@@ -2817,6 +2652,13 @@
           </a:solidFill>
           <a:ln/>
         </p:spPr>
+        <p:txBody>
+          <a:bodyPr/>
+          <a:lstStyle/>
+          <a:p>
+            <a:endParaRPr lang="zh-CN" altLang="en-US"/>
+          </a:p>
+        </p:txBody>
       </p:sp>
       <p:sp>
         <p:nvSpPr>
@@ -2839,7 +2681,7 @@
           <a:bodyPr wrap="square" lIns="0" tIns="0" rIns="0" bIns="0" rtlCol="0" anchor="ctr"/>
           <a:lstStyle/>
           <a:p>
-            <a:pPr indent="0" marL="0">
+            <a:pPr marL="0" indent="0">
               <a:buNone/>
             </a:pPr>
             <a:r>
@@ -2878,7 +2720,7 @@
           <a:bodyPr wrap="square" lIns="0" tIns="0" rIns="0" bIns="0" rtlCol="0" anchor="ctr"/>
           <a:lstStyle/>
           <a:p>
-            <a:pPr indent="0" marL="0">
+            <a:pPr marL="0" indent="0">
               <a:buNone/>
             </a:pPr>
             <a:r>
@@ -2917,11 +2759,11 @@
           <a:bodyPr wrap="square" lIns="0" tIns="0" rIns="0" bIns="0" rtlCol="0" anchor="ctr"/>
           <a:lstStyle/>
           <a:p>
-            <a:pPr indent="0" marL="0">
-              <a:buNone/>
-            </a:pPr>
-            <a:r>
-              <a:rPr lang="en-US" sz="1000" spc="200" kern="0" dirty="0">
+            <a:pPr marL="0" indent="0">
+              <a:buNone/>
+            </a:pPr>
+            <a:r>
+              <a:rPr lang="en-US" sz="1000" kern="0" spc="200" dirty="0">
                 <a:solidFill>
                   <a:srgbClr val="C9A96E"/>
                 </a:solidFill>
@@ -2956,7 +2798,7 @@
           <a:bodyPr wrap="square" lIns="0" tIns="0" rIns="0" bIns="0" rtlCol="0" anchor="ctr"/>
           <a:lstStyle/>
           <a:p>
-            <a:pPr indent="0" marL="0">
+            <a:pPr marL="0" indent="0">
               <a:lnSpc>
                 <a:spcPct val="150000"/>
               </a:lnSpc>
@@ -2976,7 +2818,7 @@
             <a:endParaRPr lang="en-US" sz="950" dirty="0"/>
           </a:p>
           <a:p>
-            <a:pPr indent="0" marL="0">
+            <a:pPr marL="0" indent="0">
               <a:lnSpc>
                 <a:spcPct val="150000"/>
               </a:lnSpc>
@@ -3018,7 +2860,7 @@
           <a:bodyPr wrap="square" lIns="0" tIns="0" rIns="0" bIns="0" rtlCol="0" anchor="ctr"/>
           <a:lstStyle/>
           <a:p>
-            <a:pPr algn="ctr" indent="0" marL="0">
+            <a:pPr marL="0" indent="0" algn="ctr">
               <a:buNone/>
             </a:pPr>
             <a:r>
@@ -3032,7 +2874,7 @@
             <a:endParaRPr lang="en-US" sz="1100" dirty="0"/>
           </a:p>
           <a:p>
-            <a:pPr algn="ctr" indent="0" marL="0">
+            <a:pPr marL="0" indent="0" algn="ctr">
               <a:buNone/>
             </a:pPr>
             <a:r>
@@ -3071,11 +2913,11 @@
           <a:bodyPr wrap="square" rtlCol="0" anchor="ctr"/>
           <a:lstStyle/>
           <a:p>
-            <a:pPr indent="0" marL="0">
-              <a:buNone/>
-            </a:pPr>
-            <a:r>
-              <a:rPr lang="en-US" sz="800" spc="200" kern="0" dirty="0">
+            <a:pPr marL="0" indent="0">
+              <a:buNone/>
+            </a:pPr>
+            <a:r>
+              <a:rPr lang="en-US" sz="800" kern="0" spc="200" dirty="0">
                 <a:solidFill>
                   <a:srgbClr val="8A95A5"/>
                 </a:solidFill>
@@ -3110,11 +2952,11 @@
           <a:bodyPr wrap="square" rtlCol="0" anchor="ctr"/>
           <a:lstStyle/>
           <a:p>
-            <a:pPr algn="r" indent="0" marL="0">
-              <a:buNone/>
-            </a:pPr>
-            <a:r>
-              <a:rPr lang="en-US" sz="900" spc="300" kern="0" dirty="0">
+            <a:pPr marL="0" indent="0" algn="r">
+              <a:buNone/>
+            </a:pPr>
+            <a:r>
+              <a:rPr lang="en-US" sz="900" kern="0" spc="300" dirty="0">
                 <a:solidFill>
                   <a:srgbClr val="C9A96E"/>
                 </a:solidFill>
@@ -3150,6 +2992,13 @@
             <a:prstDash val="solid"/>
           </a:ln>
         </p:spPr>
+        <p:txBody>
+          <a:bodyPr/>
+          <a:lstStyle/>
+          <a:p>
+            <a:endParaRPr lang="zh-CN" altLang="en-US"/>
+          </a:p>
+        </p:txBody>
       </p:sp>
     </p:spTree>
   </p:cSld>
@@ -3167,6 +3016,7 @@
         <a:solidFill>
           <a:srgbClr val="0D1B2A"/>
         </a:solidFill>
+        <a:effectLst/>
       </p:bgPr>
     </p:bg>
     <p:spTree>
@@ -3204,7 +3054,7 @@
           <a:bodyPr wrap="square" lIns="0" tIns="0" rIns="0" bIns="0" rtlCol="0" anchor="ctr"/>
           <a:lstStyle/>
           <a:p>
-            <a:pPr indent="0" marL="0">
+            <a:pPr marL="0" indent="0">
               <a:buNone/>
             </a:pPr>
             <a:r>
@@ -3244,6 +3094,13 @@
             <a:prstDash val="solid"/>
           </a:ln>
         </p:spPr>
+        <p:txBody>
+          <a:bodyPr/>
+          <a:lstStyle/>
+          <a:p>
+            <a:endParaRPr lang="zh-CN" altLang="en-US"/>
+          </a:p>
+        </p:txBody>
       </p:sp>
       <p:sp>
         <p:nvSpPr>
@@ -3266,7 +3123,7 @@
           <a:bodyPr wrap="square" lIns="0" tIns="0" rIns="0" bIns="0" rtlCol="0" anchor="ctr"/>
           <a:lstStyle/>
           <a:p>
-            <a:pPr indent="0" marL="0">
+            <a:pPr marL="0" indent="0">
               <a:buNone/>
             </a:pPr>
             <a:r>
@@ -3280,9 +3137,6 @@
               </a:rPr>
               <a:t>5 分钟</a:t>
             </a:r>
-            <a:pPr indent="0" marL="0">
-              <a:buNone/>
-            </a:pPr>
             <a:r>
               <a:rPr lang="en-US" sz="1600" dirty="0">
                 <a:solidFill>
@@ -3307,15 +3161,20 @@
             <a:ext cx="1828800" cy="1508760"/>
           </a:xfrm>
           <a:prstGeom prst="rect">
-            <a:avLst>
-              <a:gd name="adj" fmla="val 3030"/>
-            </a:avLst>
+            <a:avLst/>
           </a:prstGeom>
           <a:solidFill>
             <a:srgbClr val="C9A96E"/>
           </a:solidFill>
           <a:ln/>
         </p:spPr>
+        <p:txBody>
+          <a:bodyPr/>
+          <a:lstStyle/>
+          <a:p>
+            <a:endParaRPr lang="zh-CN" altLang="en-US"/>
+          </a:p>
+        </p:txBody>
       </p:sp>
       <p:sp>
         <p:nvSpPr>
@@ -3338,11 +3197,11 @@
           <a:bodyPr wrap="square" lIns="0" tIns="0" rIns="0" bIns="0" rtlCol="0" anchor="ctr"/>
           <a:lstStyle/>
           <a:p>
-            <a:pPr indent="0" marL="0">
-              <a:buNone/>
-            </a:pPr>
-            <a:r>
-              <a:rPr lang="en-US" sz="1100" spc="300" kern="0" dirty="0">
+            <a:pPr marL="0" indent="0">
+              <a:buNone/>
+            </a:pPr>
+            <a:r>
+              <a:rPr lang="en-US" sz="1100" kern="0" spc="300" dirty="0">
                 <a:solidFill>
                   <a:srgbClr val="0A0A0A"/>
                 </a:solidFill>
@@ -3377,7 +3236,7 @@
           <a:bodyPr wrap="square" lIns="0" tIns="0" rIns="0" bIns="0" rtlCol="0" anchor="ctr"/>
           <a:lstStyle/>
           <a:p>
-            <a:pPr indent="0" marL="0">
+            <a:pPr marL="0" indent="0">
               <a:buNone/>
             </a:pPr>
             <a:r>
@@ -3416,7 +3275,7 @@
           <a:bodyPr wrap="square" lIns="0" tIns="0" rIns="0" bIns="0" rtlCol="0" anchor="ctr"/>
           <a:lstStyle/>
           <a:p>
-            <a:pPr indent="0" marL="0">
+            <a:pPr marL="0" indent="0">
               <a:buNone/>
             </a:pPr>
             <a:r>
@@ -3456,6 +3315,13 @@
             <a:prstDash val="solid"/>
           </a:ln>
         </p:spPr>
+        <p:txBody>
+          <a:bodyPr/>
+          <a:lstStyle/>
+          <a:p>
+            <a:endParaRPr lang="zh-CN" altLang="en-US"/>
+          </a:p>
+        </p:txBody>
       </p:sp>
       <p:sp>
         <p:nvSpPr>
@@ -3469,15 +3335,20 @@
             <a:ext cx="1828800" cy="1508760"/>
           </a:xfrm>
           <a:prstGeom prst="rect">
-            <a:avLst>
-              <a:gd name="adj" fmla="val 3030"/>
-            </a:avLst>
+            <a:avLst/>
           </a:prstGeom>
           <a:solidFill>
             <a:srgbClr val="152238"/>
           </a:solidFill>
           <a:ln/>
         </p:spPr>
+        <p:txBody>
+          <a:bodyPr/>
+          <a:lstStyle/>
+          <a:p>
+            <a:endParaRPr lang="zh-CN" altLang="en-US"/>
+          </a:p>
+        </p:txBody>
       </p:sp>
       <p:sp>
         <p:nvSpPr>
@@ -3500,11 +3371,11 @@
           <a:bodyPr wrap="square" lIns="0" tIns="0" rIns="0" bIns="0" rtlCol="0" anchor="ctr"/>
           <a:lstStyle/>
           <a:p>
-            <a:pPr indent="0" marL="0">
-              <a:buNone/>
-            </a:pPr>
-            <a:r>
-              <a:rPr lang="en-US" sz="1100" spc="300" kern="0" dirty="0">
+            <a:pPr marL="0" indent="0">
+              <a:buNone/>
+            </a:pPr>
+            <a:r>
+              <a:rPr lang="en-US" sz="1100" kern="0" spc="300" dirty="0">
                 <a:solidFill>
                   <a:srgbClr val="E8E4DD"/>
                 </a:solidFill>
@@ -3539,7 +3410,7 @@
           <a:bodyPr wrap="square" lIns="0" tIns="0" rIns="0" bIns="0" rtlCol="0" anchor="ctr"/>
           <a:lstStyle/>
           <a:p>
-            <a:pPr indent="0" marL="0">
+            <a:pPr marL="0" indent="0">
               <a:buNone/>
             </a:pPr>
             <a:r>
@@ -3578,7 +3449,7 @@
           <a:bodyPr wrap="square" lIns="0" tIns="0" rIns="0" bIns="0" rtlCol="0" anchor="ctr"/>
           <a:lstStyle/>
           <a:p>
-            <a:pPr indent="0" marL="0">
+            <a:pPr marL="0" indent="0">
               <a:buNone/>
             </a:pPr>
             <a:r>
@@ -3618,6 +3489,13 @@
             <a:prstDash val="solid"/>
           </a:ln>
         </p:spPr>
+        <p:txBody>
+          <a:bodyPr/>
+          <a:lstStyle/>
+          <a:p>
+            <a:endParaRPr lang="zh-CN" altLang="en-US"/>
+          </a:p>
+        </p:txBody>
       </p:sp>
       <p:sp>
         <p:nvSpPr>
@@ -3631,15 +3509,20 @@
             <a:ext cx="1828800" cy="1508760"/>
           </a:xfrm>
           <a:prstGeom prst="rect">
-            <a:avLst>
-              <a:gd name="adj" fmla="val 3030"/>
-            </a:avLst>
+            <a:avLst/>
           </a:prstGeom>
           <a:solidFill>
             <a:srgbClr val="152238"/>
           </a:solidFill>
           <a:ln/>
         </p:spPr>
+        <p:txBody>
+          <a:bodyPr/>
+          <a:lstStyle/>
+          <a:p>
+            <a:endParaRPr lang="zh-CN" altLang="en-US"/>
+          </a:p>
+        </p:txBody>
       </p:sp>
       <p:sp>
         <p:nvSpPr>
@@ -3662,11 +3545,11 @@
           <a:bodyPr wrap="square" lIns="0" tIns="0" rIns="0" bIns="0" rtlCol="0" anchor="ctr"/>
           <a:lstStyle/>
           <a:p>
-            <a:pPr indent="0" marL="0">
-              <a:buNone/>
-            </a:pPr>
-            <a:r>
-              <a:rPr lang="en-US" sz="1100" spc="300" kern="0" dirty="0">
+            <a:pPr marL="0" indent="0">
+              <a:buNone/>
+            </a:pPr>
+            <a:r>
+              <a:rPr lang="en-US" sz="1100" kern="0" spc="300" dirty="0">
                 <a:solidFill>
                   <a:srgbClr val="E8E4DD"/>
                 </a:solidFill>
@@ -3701,7 +3584,7 @@
           <a:bodyPr wrap="square" lIns="0" tIns="0" rIns="0" bIns="0" rtlCol="0" anchor="ctr"/>
           <a:lstStyle/>
           <a:p>
-            <a:pPr indent="0" marL="0">
+            <a:pPr marL="0" indent="0">
               <a:buNone/>
             </a:pPr>
             <a:r>
@@ -3740,7 +3623,7 @@
           <a:bodyPr wrap="square" lIns="0" tIns="0" rIns="0" bIns="0" rtlCol="0" anchor="ctr"/>
           <a:lstStyle/>
           <a:p>
-            <a:pPr indent="0" marL="0">
+            <a:pPr marL="0" indent="0">
               <a:buNone/>
             </a:pPr>
             <a:r>
@@ -3780,6 +3663,13 @@
             <a:prstDash val="solid"/>
           </a:ln>
         </p:spPr>
+        <p:txBody>
+          <a:bodyPr/>
+          <a:lstStyle/>
+          <a:p>
+            <a:endParaRPr lang="zh-CN" altLang="en-US"/>
+          </a:p>
+        </p:txBody>
       </p:sp>
       <p:sp>
         <p:nvSpPr>
@@ -3793,15 +3683,20 @@
             <a:ext cx="1828800" cy="1508760"/>
           </a:xfrm>
           <a:prstGeom prst="rect">
-            <a:avLst>
-              <a:gd name="adj" fmla="val 3030"/>
-            </a:avLst>
+            <a:avLst/>
           </a:prstGeom>
           <a:solidFill>
             <a:srgbClr val="152238"/>
           </a:solidFill>
           <a:ln/>
         </p:spPr>
+        <p:txBody>
+          <a:bodyPr/>
+          <a:lstStyle/>
+          <a:p>
+            <a:endParaRPr lang="zh-CN" altLang="en-US"/>
+          </a:p>
+        </p:txBody>
       </p:sp>
       <p:sp>
         <p:nvSpPr>
@@ -3824,11 +3719,11 @@
           <a:bodyPr wrap="square" lIns="0" tIns="0" rIns="0" bIns="0" rtlCol="0" anchor="ctr"/>
           <a:lstStyle/>
           <a:p>
-            <a:pPr indent="0" marL="0">
-              <a:buNone/>
-            </a:pPr>
-            <a:r>
-              <a:rPr lang="en-US" sz="1100" spc="300" kern="0" dirty="0">
+            <a:pPr marL="0" indent="0">
+              <a:buNone/>
+            </a:pPr>
+            <a:r>
+              <a:rPr lang="en-US" sz="1100" kern="0" spc="300" dirty="0">
                 <a:solidFill>
                   <a:srgbClr val="E8E4DD"/>
                 </a:solidFill>
@@ -3863,7 +3758,7 @@
           <a:bodyPr wrap="square" lIns="0" tIns="0" rIns="0" bIns="0" rtlCol="0" anchor="ctr"/>
           <a:lstStyle/>
           <a:p>
-            <a:pPr indent="0" marL="0">
+            <a:pPr marL="0" indent="0">
               <a:buNone/>
             </a:pPr>
             <a:r>
@@ -3902,7 +3797,7 @@
           <a:bodyPr wrap="square" lIns="0" tIns="0" rIns="0" bIns="0" rtlCol="0" anchor="ctr"/>
           <a:lstStyle/>
           <a:p>
-            <a:pPr indent="0" marL="0">
+            <a:pPr marL="0" indent="0">
               <a:buNone/>
             </a:pPr>
             <a:r>
@@ -3941,7 +3836,7 @@
           <a:bodyPr wrap="square" lIns="0" tIns="0" rIns="0" bIns="0" rtlCol="0" anchor="ctr"/>
           <a:lstStyle/>
           <a:p>
-            <a:pPr algn="ctr" indent="0" marL="0">
+            <a:pPr marL="0" indent="0" algn="ctr">
               <a:buNone/>
             </a:pPr>
             <a:r>
@@ -3980,7 +3875,7 @@
           <a:bodyPr wrap="square" lIns="0" tIns="0" rIns="0" bIns="0" rtlCol="0" anchor="ctr"/>
           <a:lstStyle/>
           <a:p>
-            <a:pPr algn="ctr" indent="0" marL="0">
+            <a:pPr marL="0" indent="0" algn="ctr">
               <a:buNone/>
             </a:pPr>
             <a:r>
@@ -4019,7 +3914,7 @@
           <a:bodyPr wrap="square" lIns="0" tIns="0" rIns="0" bIns="0" rtlCol="0" anchor="ctr"/>
           <a:lstStyle/>
           <a:p>
-            <a:pPr algn="ctr" indent="0" marL="0">
+            <a:pPr marL="0" indent="0" algn="ctr">
               <a:buNone/>
             </a:pPr>
             <a:r>
@@ -4058,7 +3953,7 @@
           <a:bodyPr wrap="square" lIns="0" tIns="0" rIns="0" bIns="0" rtlCol="0" anchor="ctr"/>
           <a:lstStyle/>
           <a:p>
-            <a:pPr algn="ctr" indent="0" marL="0">
+            <a:pPr marL="0" indent="0" algn="ctr">
               <a:buNone/>
             </a:pPr>
             <a:r>
@@ -4097,7 +3992,7 @@
           <a:bodyPr wrap="square" lIns="0" tIns="0" rIns="0" bIns="0" rtlCol="0" anchor="ctr"/>
           <a:lstStyle/>
           <a:p>
-            <a:pPr algn="ctr" indent="0" marL="0">
+            <a:pPr marL="0" indent="0" algn="ctr">
               <a:buNone/>
             </a:pPr>
             <a:r>
@@ -4136,7 +4031,7 @@
           <a:bodyPr wrap="square" lIns="0" tIns="0" rIns="0" bIns="0" rtlCol="0" anchor="ctr"/>
           <a:lstStyle/>
           <a:p>
-            <a:pPr algn="ctr" indent="0" marL="0">
+            <a:pPr marL="0" indent="0" algn="ctr">
               <a:buNone/>
             </a:pPr>
             <a:r>
@@ -4175,7 +4070,7 @@
           <a:bodyPr wrap="square" lIns="0" tIns="0" rIns="0" bIns="0" rtlCol="0" anchor="ctr"/>
           <a:lstStyle/>
           <a:p>
-            <a:pPr algn="ctr" indent="0" marL="0">
+            <a:pPr marL="0" indent="0" algn="ctr">
               <a:buNone/>
             </a:pPr>
             <a:r>
@@ -4214,7 +4109,7 @@
           <a:bodyPr wrap="square" lIns="0" tIns="0" rIns="0" bIns="0" rtlCol="0" anchor="ctr"/>
           <a:lstStyle/>
           <a:p>
-            <a:pPr algn="ctr" indent="0" marL="0">
+            <a:pPr marL="0" indent="0" algn="ctr">
               <a:buNone/>
             </a:pPr>
             <a:r>
@@ -4253,7 +4148,7 @@
           <a:bodyPr wrap="square" lIns="0" tIns="0" rIns="0" bIns="0" rtlCol="0" anchor="ctr"/>
           <a:lstStyle/>
           <a:p>
-            <a:pPr algn="ctr" indent="0" marL="0">
+            <a:pPr marL="0" indent="0" algn="ctr">
               <a:buNone/>
             </a:pPr>
             <a:r>
@@ -4292,7 +4187,7 @@
           <a:bodyPr wrap="square" lIns="0" tIns="0" rIns="0" bIns="0" rtlCol="0" anchor="ctr"/>
           <a:lstStyle/>
           <a:p>
-            <a:pPr algn="ctr" indent="0" marL="0">
+            <a:pPr marL="0" indent="0" algn="ctr">
               <a:buNone/>
             </a:pPr>
             <a:r>
@@ -4331,7 +4226,7 @@
           <a:bodyPr wrap="square" lIns="0" tIns="0" rIns="0" bIns="0" rtlCol="0" anchor="ctr"/>
           <a:lstStyle/>
           <a:p>
-            <a:pPr algn="ctr" indent="0" marL="0">
+            <a:pPr marL="0" indent="0" algn="ctr">
               <a:buNone/>
             </a:pPr>
             <a:r>
@@ -4370,7 +4265,7 @@
           <a:bodyPr wrap="square" lIns="0" tIns="0" rIns="0" bIns="0" rtlCol="0" anchor="ctr"/>
           <a:lstStyle/>
           <a:p>
-            <a:pPr algn="ctr" indent="0" marL="0">
+            <a:pPr marL="0" indent="0" algn="ctr">
               <a:buNone/>
             </a:pPr>
             <a:r>
@@ -4409,11 +4304,11 @@
           <a:bodyPr wrap="square" rtlCol="0" anchor="ctr"/>
           <a:lstStyle/>
           <a:p>
-            <a:pPr indent="0" marL="0">
-              <a:buNone/>
-            </a:pPr>
-            <a:r>
-              <a:rPr lang="en-US" sz="800" spc="200" kern="0" dirty="0">
+            <a:pPr marL="0" indent="0">
+              <a:buNone/>
+            </a:pPr>
+            <a:r>
+              <a:rPr lang="en-US" sz="800" kern="0" spc="200" dirty="0">
                 <a:solidFill>
                   <a:srgbClr val="8A95A5"/>
                 </a:solidFill>
@@ -4448,11 +4343,11 @@
           <a:bodyPr wrap="square" rtlCol="0" anchor="ctr"/>
           <a:lstStyle/>
           <a:p>
-            <a:pPr algn="r" indent="0" marL="0">
-              <a:buNone/>
-            </a:pPr>
-            <a:r>
-              <a:rPr lang="en-US" sz="900" spc="300" kern="0" dirty="0">
+            <a:pPr marL="0" indent="0" algn="r">
+              <a:buNone/>
+            </a:pPr>
+            <a:r>
+              <a:rPr lang="en-US" sz="900" kern="0" spc="300" dirty="0">
                 <a:solidFill>
                   <a:srgbClr val="C9A96E"/>
                 </a:solidFill>
@@ -4488,6 +4383,13 @@
             <a:prstDash val="solid"/>
           </a:ln>
         </p:spPr>
+        <p:txBody>
+          <a:bodyPr/>
+          <a:lstStyle/>
+          <a:p>
+            <a:endParaRPr lang="zh-CN" altLang="en-US"/>
+          </a:p>
+        </p:txBody>
       </p:sp>
     </p:spTree>
   </p:cSld>
@@ -4505,6 +4407,7 @@
         <a:solidFill>
           <a:srgbClr val="0D1B2A"/>
         </a:solidFill>
+        <a:effectLst/>
       </p:bgPr>
     </p:bg>
     <p:spTree>
@@ -4542,7 +4445,7 @@
           <a:bodyPr wrap="square" lIns="0" tIns="0" rIns="0" bIns="0" rtlCol="0" anchor="ctr"/>
           <a:lstStyle/>
           <a:p>
-            <a:pPr indent="0" marL="0">
+            <a:pPr marL="0" indent="0">
               <a:buNone/>
             </a:pPr>
             <a:r>
@@ -4582,6 +4485,13 @@
             <a:prstDash val="solid"/>
           </a:ln>
         </p:spPr>
+        <p:txBody>
+          <a:bodyPr/>
+          <a:lstStyle/>
+          <a:p>
+            <a:endParaRPr lang="zh-CN" altLang="en-US"/>
+          </a:p>
+        </p:txBody>
       </p:sp>
       <p:sp>
         <p:nvSpPr>
@@ -4604,7 +4514,7 @@
           <a:bodyPr wrap="square" lIns="0" tIns="0" rIns="0" bIns="0" rtlCol="0" anchor="ctr"/>
           <a:lstStyle/>
           <a:p>
-            <a:pPr indent="0" marL="0">
+            <a:pPr marL="0" indent="0">
               <a:buNone/>
             </a:pPr>
             <a:r>
@@ -4634,15 +4544,20 @@
             <a:ext cx="2560320" cy="1325880"/>
           </a:xfrm>
           <a:prstGeom prst="rect">
-            <a:avLst>
-              <a:gd name="adj" fmla="val 3448"/>
-            </a:avLst>
+            <a:avLst/>
           </a:prstGeom>
           <a:solidFill>
             <a:srgbClr val="152238"/>
           </a:solidFill>
           <a:ln/>
         </p:spPr>
+        <p:txBody>
+          <a:bodyPr/>
+          <a:lstStyle/>
+          <a:p>
+            <a:endParaRPr lang="zh-CN" altLang="en-US"/>
+          </a:p>
+        </p:txBody>
       </p:sp>
       <p:sp>
         <p:nvSpPr>
@@ -4663,6 +4578,13 @@
           </a:solidFill>
           <a:ln/>
         </p:spPr>
+        <p:txBody>
+          <a:bodyPr/>
+          <a:lstStyle/>
+          <a:p>
+            <a:endParaRPr lang="zh-CN" altLang="en-US"/>
+          </a:p>
+        </p:txBody>
       </p:sp>
       <p:sp>
         <p:nvSpPr>
@@ -4685,7 +4607,7 @@
           <a:bodyPr wrap="square" lIns="0" tIns="0" rIns="0" bIns="0" rtlCol="0" anchor="ctr"/>
           <a:lstStyle/>
           <a:p>
-            <a:pPr indent="0" marL="0">
+            <a:pPr marL="0" indent="0">
               <a:buNone/>
             </a:pPr>
             <a:r>
@@ -4724,7 +4646,7 @@
           <a:bodyPr wrap="square" lIns="0" tIns="0" rIns="0" bIns="0" rtlCol="0" anchor="ctr"/>
           <a:lstStyle/>
           <a:p>
-            <a:pPr indent="0" marL="0">
+            <a:pPr marL="0" indent="0">
               <a:buNone/>
             </a:pPr>
             <a:r>
@@ -4735,9 +4657,6 @@
               </a:rPr>
               <a:t>全球</a:t>
             </a:r>
-            <a:pPr indent="0" marL="0">
-              <a:buNone/>
-            </a:pPr>
             <a:r>
               <a:rPr lang="en-US" sz="800" dirty="0">
                 <a:solidFill>
@@ -4746,9 +4665,6 @@
               </a:rPr>
               <a:t>  ·  </a:t>
             </a:r>
-            <a:pPr indent="0" marL="0">
-              <a:buNone/>
-            </a:pPr>
             <a:r>
               <a:rPr lang="en-US" sz="1000" dirty="0">
                 <a:solidFill>
@@ -4782,11 +4698,11 @@
           <a:bodyPr wrap="square" lIns="0" tIns="0" rIns="0" bIns="0" rtlCol="0" anchor="ctr"/>
           <a:lstStyle/>
           <a:p>
-            <a:pPr indent="0" marL="0">
-              <a:buNone/>
-            </a:pPr>
-            <a:r>
-              <a:rPr lang="en-US" sz="900" spc="100" kern="0" dirty="0">
+            <a:pPr marL="0" indent="0">
+              <a:buNone/>
+            </a:pPr>
+            <a:r>
+              <a:rPr lang="en-US" sz="900" kern="0" spc="100" dirty="0">
                 <a:solidFill>
                   <a:srgbClr val="8A95A5"/>
                 </a:solidFill>
@@ -4812,15 +4728,20 @@
             <a:ext cx="2560320" cy="1325880"/>
           </a:xfrm>
           <a:prstGeom prst="rect">
-            <a:avLst>
-              <a:gd name="adj" fmla="val 3448"/>
-            </a:avLst>
+            <a:avLst/>
           </a:prstGeom>
           <a:solidFill>
             <a:srgbClr val="152238"/>
           </a:solidFill>
           <a:ln/>
         </p:spPr>
+        <p:txBody>
+          <a:bodyPr/>
+          <a:lstStyle/>
+          <a:p>
+            <a:endParaRPr lang="zh-CN" altLang="en-US"/>
+          </a:p>
+        </p:txBody>
       </p:sp>
       <p:sp>
         <p:nvSpPr>
@@ -4841,6 +4762,13 @@
           </a:solidFill>
           <a:ln/>
         </p:spPr>
+        <p:txBody>
+          <a:bodyPr/>
+          <a:lstStyle/>
+          <a:p>
+            <a:endParaRPr lang="zh-CN" altLang="en-US"/>
+          </a:p>
+        </p:txBody>
       </p:sp>
       <p:sp>
         <p:nvSpPr>
@@ -4863,7 +4791,7 @@
           <a:bodyPr wrap="square" lIns="0" tIns="0" rIns="0" bIns="0" rtlCol="0" anchor="ctr"/>
           <a:lstStyle/>
           <a:p>
-            <a:pPr indent="0" marL="0">
+            <a:pPr marL="0" indent="0">
               <a:buNone/>
             </a:pPr>
             <a:r>
@@ -4902,7 +4830,7 @@
           <a:bodyPr wrap="square" lIns="0" tIns="0" rIns="0" bIns="0" rtlCol="0" anchor="ctr"/>
           <a:lstStyle/>
           <a:p>
-            <a:pPr indent="0" marL="0">
+            <a:pPr marL="0" indent="0">
               <a:buNone/>
             </a:pPr>
             <a:r>
@@ -4913,9 +4841,6 @@
               </a:rPr>
               <a:t>美国</a:t>
             </a:r>
-            <a:pPr indent="0" marL="0">
-              <a:buNone/>
-            </a:pPr>
             <a:r>
               <a:rPr lang="en-US" sz="800" dirty="0">
                 <a:solidFill>
@@ -4924,9 +4849,6 @@
               </a:rPr>
               <a:t>  ·  </a:t>
             </a:r>
-            <a:pPr indent="0" marL="0">
-              <a:buNone/>
-            </a:pPr>
             <a:r>
               <a:rPr lang="en-US" sz="1000" dirty="0">
                 <a:solidFill>
@@ -4960,11 +4882,11 @@
           <a:bodyPr wrap="square" lIns="0" tIns="0" rIns="0" bIns="0" rtlCol="0" anchor="ctr"/>
           <a:lstStyle/>
           <a:p>
-            <a:pPr indent="0" marL="0">
-              <a:buNone/>
-            </a:pPr>
-            <a:r>
-              <a:rPr lang="en-US" sz="900" spc="100" kern="0" dirty="0">
+            <a:pPr marL="0" indent="0">
+              <a:buNone/>
+            </a:pPr>
+            <a:r>
+              <a:rPr lang="en-US" sz="900" kern="0" spc="100" dirty="0">
                 <a:solidFill>
                   <a:srgbClr val="8A95A5"/>
                 </a:solidFill>
@@ -4990,15 +4912,20 @@
             <a:ext cx="2560320" cy="1325880"/>
           </a:xfrm>
           <a:prstGeom prst="rect">
-            <a:avLst>
-              <a:gd name="adj" fmla="val 3448"/>
-            </a:avLst>
+            <a:avLst/>
           </a:prstGeom>
           <a:solidFill>
             <a:srgbClr val="152238"/>
           </a:solidFill>
           <a:ln/>
         </p:spPr>
+        <p:txBody>
+          <a:bodyPr/>
+          <a:lstStyle/>
+          <a:p>
+            <a:endParaRPr lang="zh-CN" altLang="en-US"/>
+          </a:p>
+        </p:txBody>
       </p:sp>
       <p:sp>
         <p:nvSpPr>
@@ -5019,6 +4946,13 @@
           </a:solidFill>
           <a:ln/>
         </p:spPr>
+        <p:txBody>
+          <a:bodyPr/>
+          <a:lstStyle/>
+          <a:p>
+            <a:endParaRPr lang="zh-CN" altLang="en-US"/>
+          </a:p>
+        </p:txBody>
       </p:sp>
       <p:sp>
         <p:nvSpPr>
@@ -5041,7 +4975,7 @@
           <a:bodyPr wrap="square" lIns="0" tIns="0" rIns="0" bIns="0" rtlCol="0" anchor="ctr"/>
           <a:lstStyle/>
           <a:p>
-            <a:pPr indent="0" marL="0">
+            <a:pPr marL="0" indent="0">
               <a:buNone/>
             </a:pPr>
             <a:r>
@@ -5080,7 +5014,7 @@
           <a:bodyPr wrap="square" lIns="0" tIns="0" rIns="0" bIns="0" rtlCol="0" anchor="ctr"/>
           <a:lstStyle/>
           <a:p>
-            <a:pPr indent="0" marL="0">
+            <a:pPr marL="0" indent="0">
               <a:buNone/>
             </a:pPr>
             <a:r>
@@ -5091,9 +5025,6 @@
               </a:rPr>
               <a:t>欧洲/全球</a:t>
             </a:r>
-            <a:pPr indent="0" marL="0">
-              <a:buNone/>
-            </a:pPr>
             <a:r>
               <a:rPr lang="en-US" sz="800" dirty="0">
                 <a:solidFill>
@@ -5102,9 +5033,6 @@
               </a:rPr>
               <a:t>  ·  </a:t>
             </a:r>
-            <a:pPr indent="0" marL="0">
-              <a:buNone/>
-            </a:pPr>
             <a:r>
               <a:rPr lang="en-US" sz="1000" dirty="0">
                 <a:solidFill>
@@ -5138,11 +5066,11 @@
           <a:bodyPr wrap="square" lIns="0" tIns="0" rIns="0" bIns="0" rtlCol="0" anchor="ctr"/>
           <a:lstStyle/>
           <a:p>
-            <a:pPr indent="0" marL="0">
-              <a:buNone/>
-            </a:pPr>
-            <a:r>
-              <a:rPr lang="en-US" sz="900" spc="100" kern="0" dirty="0">
+            <a:pPr marL="0" indent="0">
+              <a:buNone/>
+            </a:pPr>
+            <a:r>
+              <a:rPr lang="en-US" sz="900" kern="0" spc="100" dirty="0">
                 <a:solidFill>
                   <a:srgbClr val="C9A96E"/>
                 </a:solidFill>
@@ -5168,15 +5096,20 @@
             <a:ext cx="2560320" cy="1325880"/>
           </a:xfrm>
           <a:prstGeom prst="rect">
-            <a:avLst>
-              <a:gd name="adj" fmla="val 3448"/>
-            </a:avLst>
+            <a:avLst/>
           </a:prstGeom>
           <a:solidFill>
             <a:srgbClr val="152238"/>
           </a:solidFill>
           <a:ln/>
         </p:spPr>
+        <p:txBody>
+          <a:bodyPr/>
+          <a:lstStyle/>
+          <a:p>
+            <a:endParaRPr lang="zh-CN" altLang="en-US"/>
+          </a:p>
+        </p:txBody>
       </p:sp>
       <p:sp>
         <p:nvSpPr>
@@ -5197,6 +5130,13 @@
           </a:solidFill>
           <a:ln/>
         </p:spPr>
+        <p:txBody>
+          <a:bodyPr/>
+          <a:lstStyle/>
+          <a:p>
+            <a:endParaRPr lang="zh-CN" altLang="en-US"/>
+          </a:p>
+        </p:txBody>
       </p:sp>
       <p:sp>
         <p:nvSpPr>
@@ -5219,7 +5159,7 @@
           <a:bodyPr wrap="square" lIns="0" tIns="0" rIns="0" bIns="0" rtlCol="0" anchor="ctr"/>
           <a:lstStyle/>
           <a:p>
-            <a:pPr indent="0" marL="0">
+            <a:pPr marL="0" indent="0">
               <a:buNone/>
             </a:pPr>
             <a:r>
@@ -5258,7 +5198,7 @@
           <a:bodyPr wrap="square" lIns="0" tIns="0" rIns="0" bIns="0" rtlCol="0" anchor="ctr"/>
           <a:lstStyle/>
           <a:p>
-            <a:pPr indent="0" marL="0">
+            <a:pPr marL="0" indent="0">
               <a:buNone/>
             </a:pPr>
             <a:r>
@@ -5269,9 +5209,6 @@
               </a:rPr>
               <a:t>全球 PCT</a:t>
             </a:r>
-            <a:pPr indent="0" marL="0">
-              <a:buNone/>
-            </a:pPr>
             <a:r>
               <a:rPr lang="en-US" sz="800" dirty="0">
                 <a:solidFill>
@@ -5280,9 +5217,6 @@
               </a:rPr>
               <a:t>  ·  </a:t>
             </a:r>
-            <a:pPr indent="0" marL="0">
-              <a:buNone/>
-            </a:pPr>
             <a:r>
               <a:rPr lang="en-US" sz="1000" dirty="0">
                 <a:solidFill>
@@ -5316,11 +5250,11 @@
           <a:bodyPr wrap="square" lIns="0" tIns="0" rIns="0" bIns="0" rtlCol="0" anchor="ctr"/>
           <a:lstStyle/>
           <a:p>
-            <a:pPr indent="0" marL="0">
-              <a:buNone/>
-            </a:pPr>
-            <a:r>
-              <a:rPr lang="en-US" sz="900" spc="100" kern="0" dirty="0">
+            <a:pPr marL="0" indent="0">
+              <a:buNone/>
+            </a:pPr>
+            <a:r>
+              <a:rPr lang="en-US" sz="900" kern="0" spc="100" dirty="0">
                 <a:solidFill>
                   <a:srgbClr val="C9A96E"/>
                 </a:solidFill>
@@ -5346,15 +5280,20 @@
             <a:ext cx="2560320" cy="1325880"/>
           </a:xfrm>
           <a:prstGeom prst="rect">
-            <a:avLst>
-              <a:gd name="adj" fmla="val 3448"/>
-            </a:avLst>
+            <a:avLst/>
           </a:prstGeom>
           <a:solidFill>
             <a:srgbClr val="152238"/>
           </a:solidFill>
           <a:ln/>
         </p:spPr>
+        <p:txBody>
+          <a:bodyPr/>
+          <a:lstStyle/>
+          <a:p>
+            <a:endParaRPr lang="zh-CN" altLang="en-US"/>
+          </a:p>
+        </p:txBody>
       </p:sp>
       <p:sp>
         <p:nvSpPr>
@@ -5375,6 +5314,13 @@
           </a:solidFill>
           <a:ln/>
         </p:spPr>
+        <p:txBody>
+          <a:bodyPr/>
+          <a:lstStyle/>
+          <a:p>
+            <a:endParaRPr lang="zh-CN" altLang="en-US"/>
+          </a:p>
+        </p:txBody>
       </p:sp>
       <p:sp>
         <p:nvSpPr>
@@ -5397,7 +5343,7 @@
           <a:bodyPr wrap="square" lIns="0" tIns="0" rIns="0" bIns="0" rtlCol="0" anchor="ctr"/>
           <a:lstStyle/>
           <a:p>
-            <a:pPr indent="0" marL="0">
+            <a:pPr marL="0" indent="0">
               <a:buNone/>
             </a:pPr>
             <a:r>
@@ -5436,7 +5382,7 @@
           <a:bodyPr wrap="square" lIns="0" tIns="0" rIns="0" bIns="0" rtlCol="0" anchor="ctr"/>
           <a:lstStyle/>
           <a:p>
-            <a:pPr indent="0" marL="0">
+            <a:pPr marL="0" indent="0">
               <a:buNone/>
             </a:pPr>
             <a:r>
@@ -5447,9 +5393,6 @@
               </a:rPr>
               <a:t>全球学术</a:t>
             </a:r>
-            <a:pPr indent="0" marL="0">
-              <a:buNone/>
-            </a:pPr>
             <a:r>
               <a:rPr lang="en-US" sz="800" dirty="0">
                 <a:solidFill>
@@ -5458,9 +5401,6 @@
               </a:rPr>
               <a:t>  ·  </a:t>
             </a:r>
-            <a:pPr indent="0" marL="0">
-              <a:buNone/>
-            </a:pPr>
             <a:r>
               <a:rPr lang="en-US" sz="1000" dirty="0">
                 <a:solidFill>
@@ -5494,11 +5434,11 @@
           <a:bodyPr wrap="square" lIns="0" tIns="0" rIns="0" bIns="0" rtlCol="0" anchor="ctr"/>
           <a:lstStyle/>
           <a:p>
-            <a:pPr indent="0" marL="0">
-              <a:buNone/>
-            </a:pPr>
-            <a:r>
-              <a:rPr lang="en-US" sz="900" spc="100" kern="0" dirty="0">
+            <a:pPr marL="0" indent="0">
+              <a:buNone/>
+            </a:pPr>
+            <a:r>
+              <a:rPr lang="en-US" sz="900" kern="0" spc="100" dirty="0">
                 <a:solidFill>
                   <a:srgbClr val="C9A96E"/>
                 </a:solidFill>
@@ -5524,15 +5464,20 @@
             <a:ext cx="2560320" cy="1325880"/>
           </a:xfrm>
           <a:prstGeom prst="rect">
-            <a:avLst>
-              <a:gd name="adj" fmla="val 3448"/>
-            </a:avLst>
+            <a:avLst/>
           </a:prstGeom>
           <a:solidFill>
             <a:srgbClr val="152238"/>
           </a:solidFill>
           <a:ln/>
         </p:spPr>
+        <p:txBody>
+          <a:bodyPr/>
+          <a:lstStyle/>
+          <a:p>
+            <a:endParaRPr lang="zh-CN" altLang="en-US"/>
+          </a:p>
+        </p:txBody>
       </p:sp>
       <p:sp>
         <p:nvSpPr>
@@ -5553,6 +5498,13 @@
           </a:solidFill>
           <a:ln/>
         </p:spPr>
+        <p:txBody>
+          <a:bodyPr/>
+          <a:lstStyle/>
+          <a:p>
+            <a:endParaRPr lang="zh-CN" altLang="en-US"/>
+          </a:p>
+        </p:txBody>
       </p:sp>
       <p:sp>
         <p:nvSpPr>
@@ -5575,7 +5527,7 @@
           <a:bodyPr wrap="square" lIns="0" tIns="0" rIns="0" bIns="0" rtlCol="0" anchor="ctr"/>
           <a:lstStyle/>
           <a:p>
-            <a:pPr indent="0" marL="0">
+            <a:pPr marL="0" indent="0">
               <a:buNone/>
             </a:pPr>
             <a:r>
@@ -5614,7 +5566,7 @@
           <a:bodyPr wrap="square" lIns="0" tIns="0" rIns="0" bIns="0" rtlCol="0" anchor="ctr"/>
           <a:lstStyle/>
           <a:p>
-            <a:pPr indent="0" marL="0">
+            <a:pPr marL="0" indent="0">
               <a:buNone/>
             </a:pPr>
             <a:r>
@@ -5625,9 +5577,6 @@
               </a:rPr>
               <a:t>训练知识</a:t>
             </a:r>
-            <a:pPr indent="0" marL="0">
-              <a:buNone/>
-            </a:pPr>
             <a:r>
               <a:rPr lang="en-US" sz="800" dirty="0">
                 <a:solidFill>
@@ -5636,9 +5585,6 @@
               </a:rPr>
               <a:t>  ·  </a:t>
             </a:r>
-            <a:pPr indent="0" marL="0">
-              <a:buNone/>
-            </a:pPr>
             <a:r>
               <a:rPr lang="en-US" sz="1000" dirty="0">
                 <a:solidFill>
@@ -5672,11 +5618,11 @@
           <a:bodyPr wrap="square" lIns="0" tIns="0" rIns="0" bIns="0" rtlCol="0" anchor="ctr"/>
           <a:lstStyle/>
           <a:p>
-            <a:pPr indent="0" marL="0">
-              <a:buNone/>
-            </a:pPr>
-            <a:r>
-              <a:rPr lang="en-US" sz="900" spc="100" kern="0" dirty="0">
+            <a:pPr marL="0" indent="0">
+              <a:buNone/>
+            </a:pPr>
+            <a:r>
+              <a:rPr lang="en-US" sz="900" kern="0" spc="100" dirty="0">
                 <a:solidFill>
                   <a:srgbClr val="C9A96E"/>
                 </a:solidFill>
@@ -5711,11 +5657,11 @@
           <a:bodyPr wrap="square" rtlCol="0" anchor="ctr"/>
           <a:lstStyle/>
           <a:p>
-            <a:pPr indent="0" marL="0">
-              <a:buNone/>
-            </a:pPr>
-            <a:r>
-              <a:rPr lang="en-US" sz="800" spc="200" kern="0" dirty="0">
+            <a:pPr marL="0" indent="0">
+              <a:buNone/>
+            </a:pPr>
+            <a:r>
+              <a:rPr lang="en-US" sz="800" kern="0" spc="200" dirty="0">
                 <a:solidFill>
                   <a:srgbClr val="8A95A5"/>
                 </a:solidFill>
@@ -5750,11 +5696,11 @@
           <a:bodyPr wrap="square" rtlCol="0" anchor="ctr"/>
           <a:lstStyle/>
           <a:p>
-            <a:pPr algn="r" indent="0" marL="0">
-              <a:buNone/>
-            </a:pPr>
-            <a:r>
-              <a:rPr lang="en-US" sz="900" spc="300" kern="0" dirty="0">
+            <a:pPr marL="0" indent="0" algn="r">
+              <a:buNone/>
+            </a:pPr>
+            <a:r>
+              <a:rPr lang="en-US" sz="900" kern="0" spc="300" dirty="0">
                 <a:solidFill>
                   <a:srgbClr val="C9A96E"/>
                 </a:solidFill>
@@ -5790,6 +5736,13 @@
             <a:prstDash val="solid"/>
           </a:ln>
         </p:spPr>
+        <p:txBody>
+          <a:bodyPr/>
+          <a:lstStyle/>
+          <a:p>
+            <a:endParaRPr lang="zh-CN" altLang="en-US"/>
+          </a:p>
+        </p:txBody>
       </p:sp>
     </p:spTree>
   </p:cSld>
@@ -5807,6 +5760,7 @@
         <a:solidFill>
           <a:srgbClr val="0D1B2A"/>
         </a:solidFill>
+        <a:effectLst/>
       </p:bgPr>
     </p:bg>
     <p:spTree>
@@ -5844,7 +5798,7 @@
           <a:bodyPr wrap="square" lIns="0" tIns="0" rIns="0" bIns="0" rtlCol="0" anchor="ctr"/>
           <a:lstStyle/>
           <a:p>
-            <a:pPr indent="0" marL="0">
+            <a:pPr marL="0" indent="0">
               <a:buNone/>
             </a:pPr>
             <a:r>
@@ -5884,6 +5838,13 @@
             <a:prstDash val="solid"/>
           </a:ln>
         </p:spPr>
+        <p:txBody>
+          <a:bodyPr/>
+          <a:lstStyle/>
+          <a:p>
+            <a:endParaRPr lang="zh-CN" altLang="en-US"/>
+          </a:p>
+        </p:txBody>
       </p:sp>
       <p:sp>
         <p:nvSpPr>
@@ -5897,15 +5858,20 @@
             <a:ext cx="5303520" cy="3291840"/>
           </a:xfrm>
           <a:prstGeom prst="rect">
-            <a:avLst>
-              <a:gd name="adj" fmla="val 1389"/>
-            </a:avLst>
+            <a:avLst/>
           </a:prstGeom>
           <a:solidFill>
             <a:srgbClr val="152238"/>
           </a:solidFill>
           <a:ln/>
         </p:spPr>
+        <p:txBody>
+          <a:bodyPr/>
+          <a:lstStyle/>
+          <a:p>
+            <a:endParaRPr lang="zh-CN" altLang="en-US"/>
+          </a:p>
+        </p:txBody>
       </p:sp>
       <p:sp>
         <p:nvSpPr>
@@ -5928,11 +5894,11 @@
           <a:bodyPr wrap="square" lIns="0" tIns="0" rIns="0" bIns="0" rtlCol="0" anchor="ctr"/>
           <a:lstStyle/>
           <a:p>
-            <a:pPr indent="0" marL="0">
-              <a:buNone/>
-            </a:pPr>
-            <a:r>
-              <a:rPr lang="en-US" sz="1000" spc="100" kern="0" dirty="0">
+            <a:pPr marL="0" indent="0">
+              <a:buNone/>
+            </a:pPr>
+            <a:r>
+              <a:rPr lang="en-US" sz="1000" kern="0" spc="100" dirty="0">
                 <a:solidFill>
                   <a:srgbClr val="C9A96E"/>
                 </a:solidFill>
@@ -5967,7 +5933,7 @@
           <a:bodyPr wrap="square" lIns="0" tIns="0" rIns="0" bIns="0" rtlCol="0" anchor="ctr"/>
           <a:lstStyle/>
           <a:p>
-            <a:pPr indent="0" marL="0">
+            <a:pPr marL="0" indent="0">
               <a:buNone/>
             </a:pPr>
             <a:r>
@@ -6004,6 +5970,13 @@
           </a:solidFill>
           <a:ln/>
         </p:spPr>
+        <p:txBody>
+          <a:bodyPr/>
+          <a:lstStyle/>
+          <a:p>
+            <a:endParaRPr lang="zh-CN" altLang="en-US"/>
+          </a:p>
+        </p:txBody>
       </p:sp>
       <p:sp>
         <p:nvSpPr>
@@ -6026,11 +5999,11 @@
           <a:bodyPr wrap="square" lIns="0" tIns="0" rIns="0" bIns="0" rtlCol="0" anchor="ctr"/>
           <a:lstStyle/>
           <a:p>
-            <a:pPr indent="0" marL="0">
-              <a:buNone/>
-            </a:pPr>
-            <a:r>
-              <a:rPr lang="en-US" sz="700" spc="200" kern="0" dirty="0">
+            <a:pPr marL="0" indent="0">
+              <a:buNone/>
+            </a:pPr>
+            <a:r>
+              <a:rPr lang="en-US" sz="700" kern="0" spc="200" dirty="0">
                 <a:solidFill>
                   <a:srgbClr val="C9A96E"/>
                 </a:solidFill>
@@ -6065,7 +6038,7 @@
           <a:bodyPr wrap="square" lIns="0" tIns="0" rIns="0" bIns="0" rtlCol="0" anchor="ctr"/>
           <a:lstStyle/>
           <a:p>
-            <a:pPr indent="0" marL="0">
+            <a:pPr marL="0" indent="0">
               <a:buNone/>
             </a:pPr>
             <a:r>
@@ -6102,6 +6075,13 @@
           </a:solidFill>
           <a:ln/>
         </p:spPr>
+        <p:txBody>
+          <a:bodyPr/>
+          <a:lstStyle/>
+          <a:p>
+            <a:endParaRPr lang="zh-CN" altLang="en-US"/>
+          </a:p>
+        </p:txBody>
       </p:sp>
       <p:sp>
         <p:nvSpPr>
@@ -6124,11 +6104,11 @@
           <a:bodyPr wrap="square" lIns="0" tIns="0" rIns="0" bIns="0" rtlCol="0" anchor="ctr"/>
           <a:lstStyle/>
           <a:p>
-            <a:pPr indent="0" marL="0">
-              <a:buNone/>
-            </a:pPr>
-            <a:r>
-              <a:rPr lang="en-US" sz="700" spc="200" kern="0" dirty="0">
+            <a:pPr marL="0" indent="0">
+              <a:buNone/>
+            </a:pPr>
+            <a:r>
+              <a:rPr lang="en-US" sz="700" kern="0" spc="200" dirty="0">
                 <a:solidFill>
                   <a:srgbClr val="C9A96E"/>
                 </a:solidFill>
@@ -6163,7 +6143,7 @@
           <a:bodyPr wrap="square" lIns="0" tIns="0" rIns="0" bIns="0" rtlCol="0" anchor="ctr"/>
           <a:lstStyle/>
           <a:p>
-            <a:pPr indent="0" marL="0">
+            <a:pPr marL="0" indent="0">
               <a:buNone/>
             </a:pPr>
             <a:r>
@@ -6200,6 +6180,13 @@
           </a:solidFill>
           <a:ln/>
         </p:spPr>
+        <p:txBody>
+          <a:bodyPr/>
+          <a:lstStyle/>
+          <a:p>
+            <a:endParaRPr lang="zh-CN" altLang="en-US"/>
+          </a:p>
+        </p:txBody>
       </p:sp>
       <p:sp>
         <p:nvSpPr>
@@ -6222,11 +6209,11 @@
           <a:bodyPr wrap="square" lIns="0" tIns="0" rIns="0" bIns="0" rtlCol="0" anchor="ctr"/>
           <a:lstStyle/>
           <a:p>
-            <a:pPr indent="0" marL="0">
-              <a:buNone/>
-            </a:pPr>
-            <a:r>
-              <a:rPr lang="en-US" sz="700" spc="200" kern="0" dirty="0">
+            <a:pPr marL="0" indent="0">
+              <a:buNone/>
+            </a:pPr>
+            <a:r>
+              <a:rPr lang="en-US" sz="700" kern="0" spc="200" dirty="0">
                 <a:solidFill>
                   <a:srgbClr val="C9A96E"/>
                 </a:solidFill>
@@ -6261,7 +6248,7 @@
           <a:bodyPr wrap="square" lIns="0" tIns="0" rIns="0" bIns="0" rtlCol="0" anchor="ctr"/>
           <a:lstStyle/>
           <a:p>
-            <a:pPr indent="0" marL="0">
+            <a:pPr marL="0" indent="0">
               <a:buNone/>
             </a:pPr>
             <a:r>
@@ -6298,6 +6285,13 @@
           </a:solidFill>
           <a:ln/>
         </p:spPr>
+        <p:txBody>
+          <a:bodyPr/>
+          <a:lstStyle/>
+          <a:p>
+            <a:endParaRPr lang="zh-CN" altLang="en-US"/>
+          </a:p>
+        </p:txBody>
       </p:sp>
       <p:sp>
         <p:nvSpPr>
@@ -6320,11 +6314,11 @@
           <a:bodyPr wrap="square" lIns="0" tIns="0" rIns="0" bIns="0" rtlCol="0" anchor="ctr"/>
           <a:lstStyle/>
           <a:p>
-            <a:pPr indent="0" marL="0">
-              <a:buNone/>
-            </a:pPr>
-            <a:r>
-              <a:rPr lang="en-US" sz="700" spc="200" kern="0" dirty="0">
+            <a:pPr marL="0" indent="0">
+              <a:buNone/>
+            </a:pPr>
+            <a:r>
+              <a:rPr lang="en-US" sz="700" kern="0" spc="200" dirty="0">
                 <a:solidFill>
                   <a:srgbClr val="C9A96E"/>
                 </a:solidFill>
@@ -6359,7 +6353,7 @@
           <a:bodyPr wrap="square" lIns="0" tIns="0" rIns="0" bIns="0" rtlCol="0" anchor="ctr"/>
           <a:lstStyle/>
           <a:p>
-            <a:pPr indent="0" marL="0">
+            <a:pPr marL="0" indent="0">
               <a:buNone/>
             </a:pPr>
             <a:r>
@@ -6398,7 +6392,7 @@
           <a:bodyPr wrap="square" lIns="0" tIns="0" rIns="0" bIns="0" rtlCol="0" anchor="ctr"/>
           <a:lstStyle/>
           <a:p>
-            <a:pPr indent="0" marL="0">
+            <a:pPr marL="0" indent="0">
               <a:buNone/>
             </a:pPr>
             <a:r>
@@ -6437,7 +6431,7 @@
           <a:bodyPr wrap="square" lIns="0" tIns="0" rIns="0" bIns="0" rtlCol="0" anchor="ctr"/>
           <a:lstStyle/>
           <a:p>
-            <a:pPr indent="0" marL="0">
+            <a:pPr marL="0" indent="0">
               <a:buNone/>
             </a:pPr>
             <a:r>
@@ -6476,7 +6470,7 @@
           <a:bodyPr wrap="square" lIns="0" tIns="0" rIns="0" bIns="0" rtlCol="0" anchor="ctr"/>
           <a:lstStyle/>
           <a:p>
-            <a:pPr indent="0" marL="0">
+            <a:pPr marL="0" indent="0">
               <a:buNone/>
             </a:pPr>
             <a:r>
@@ -6515,7 +6509,7 @@
           <a:bodyPr wrap="square" lIns="0" tIns="0" rIns="0" bIns="0" rtlCol="0" anchor="ctr"/>
           <a:lstStyle/>
           <a:p>
-            <a:pPr indent="0" marL="0">
+            <a:pPr marL="0" indent="0">
               <a:buNone/>
             </a:pPr>
             <a:r>
@@ -6554,7 +6548,7 @@
           <a:bodyPr wrap="square" lIns="0" tIns="0" rIns="0" bIns="0" rtlCol="0" anchor="ctr"/>
           <a:lstStyle/>
           <a:p>
-            <a:pPr indent="0" marL="0">
+            <a:pPr marL="0" indent="0">
               <a:buNone/>
             </a:pPr>
             <a:r>
@@ -6593,7 +6587,7 @@
           <a:bodyPr wrap="square" lIns="0" tIns="0" rIns="0" bIns="0" rtlCol="0" anchor="ctr"/>
           <a:lstStyle/>
           <a:p>
-            <a:pPr indent="0" marL="0">
+            <a:pPr marL="0" indent="0">
               <a:buNone/>
             </a:pPr>
             <a:r>
@@ -6632,7 +6626,7 @@
           <a:bodyPr wrap="square" lIns="0" tIns="0" rIns="0" bIns="0" rtlCol="0" anchor="ctr"/>
           <a:lstStyle/>
           <a:p>
-            <a:pPr indent="0" marL="0">
+            <a:pPr marL="0" indent="0">
               <a:buNone/>
             </a:pPr>
             <a:r>
@@ -6671,7 +6665,7 @@
           <a:bodyPr wrap="square" lIns="0" tIns="0" rIns="0" bIns="0" rtlCol="0" anchor="ctr"/>
           <a:lstStyle/>
           <a:p>
-            <a:pPr indent="0" marL="0">
+            <a:pPr marL="0" indent="0">
               <a:buNone/>
             </a:pPr>
             <a:r>
@@ -6710,7 +6704,7 @@
           <a:bodyPr wrap="square" lIns="0" tIns="0" rIns="0" bIns="0" rtlCol="0" anchor="ctr"/>
           <a:lstStyle/>
           <a:p>
-            <a:pPr indent="0" marL="0">
+            <a:pPr marL="0" indent="0">
               <a:buNone/>
             </a:pPr>
             <a:r>
@@ -6749,7 +6743,7 @@
           <a:bodyPr wrap="square" lIns="0" tIns="0" rIns="0" bIns="0" rtlCol="0" anchor="ctr"/>
           <a:lstStyle/>
           <a:p>
-            <a:pPr indent="0" marL="0">
+            <a:pPr marL="0" indent="0">
               <a:buNone/>
             </a:pPr>
             <a:r>
@@ -6788,7 +6782,7 @@
           <a:bodyPr wrap="square" lIns="0" tIns="0" rIns="0" bIns="0" rtlCol="0" anchor="ctr"/>
           <a:lstStyle/>
           <a:p>
-            <a:pPr indent="0" marL="0">
+            <a:pPr marL="0" indent="0">
               <a:buNone/>
             </a:pPr>
             <a:r>
@@ -6827,11 +6821,11 @@
           <a:bodyPr wrap="square" rtlCol="0" anchor="ctr"/>
           <a:lstStyle/>
           <a:p>
-            <a:pPr indent="0" marL="0">
-              <a:buNone/>
-            </a:pPr>
-            <a:r>
-              <a:rPr lang="en-US" sz="800" spc="200" kern="0" dirty="0">
+            <a:pPr marL="0" indent="0">
+              <a:buNone/>
+            </a:pPr>
+            <a:r>
+              <a:rPr lang="en-US" sz="800" kern="0" spc="200" dirty="0">
                 <a:solidFill>
                   <a:srgbClr val="8A95A5"/>
                 </a:solidFill>
@@ -6866,11 +6860,11 @@
           <a:bodyPr wrap="square" rtlCol="0" anchor="ctr"/>
           <a:lstStyle/>
           <a:p>
-            <a:pPr algn="r" indent="0" marL="0">
-              <a:buNone/>
-            </a:pPr>
-            <a:r>
-              <a:rPr lang="en-US" sz="900" spc="300" kern="0" dirty="0">
+            <a:pPr marL="0" indent="0" algn="r">
+              <a:buNone/>
+            </a:pPr>
+            <a:r>
+              <a:rPr lang="en-US" sz="900" kern="0" spc="300" dirty="0">
                 <a:solidFill>
                   <a:srgbClr val="C9A96E"/>
                 </a:solidFill>
@@ -6906,6 +6900,13 @@
             <a:prstDash val="solid"/>
           </a:ln>
         </p:spPr>
+        <p:txBody>
+          <a:bodyPr/>
+          <a:lstStyle/>
+          <a:p>
+            <a:endParaRPr lang="zh-CN" altLang="en-US"/>
+          </a:p>
+        </p:txBody>
       </p:sp>
     </p:spTree>
   </p:cSld>
@@ -6923,6 +6924,7 @@
         <a:solidFill>
           <a:srgbClr val="0D1B2A"/>
         </a:solidFill>
+        <a:effectLst/>
       </p:bgPr>
     </p:bg>
     <p:spTree>
@@ -6960,7 +6962,7 @@
           <a:bodyPr wrap="square" lIns="0" tIns="0" rIns="0" bIns="0" rtlCol="0" anchor="ctr"/>
           <a:lstStyle/>
           <a:p>
-            <a:pPr indent="0" marL="0">
+            <a:pPr marL="0" indent="0">
               <a:buNone/>
             </a:pPr>
             <a:r>
@@ -7000,6 +7002,13 @@
             <a:prstDash val="solid"/>
           </a:ln>
         </p:spPr>
+        <p:txBody>
+          <a:bodyPr/>
+          <a:lstStyle/>
+          <a:p>
+            <a:endParaRPr lang="zh-CN" altLang="en-US"/>
+          </a:p>
+        </p:txBody>
       </p:sp>
       <p:sp>
         <p:nvSpPr>
@@ -7013,15 +7022,20 @@
             <a:ext cx="2560320" cy="658368"/>
           </a:xfrm>
           <a:prstGeom prst="rect">
-            <a:avLst>
-              <a:gd name="adj" fmla="val 6944"/>
-            </a:avLst>
+            <a:avLst/>
           </a:prstGeom>
           <a:solidFill>
             <a:srgbClr val="C9A96E"/>
           </a:solidFill>
           <a:ln/>
         </p:spPr>
+        <p:txBody>
+          <a:bodyPr/>
+          <a:lstStyle/>
+          <a:p>
+            <a:endParaRPr lang="zh-CN" altLang="en-US"/>
+          </a:p>
+        </p:txBody>
       </p:sp>
       <p:sp>
         <p:nvSpPr>
@@ -7044,7 +7058,7 @@
           <a:bodyPr wrap="square" lIns="0" tIns="0" rIns="0" bIns="0" rtlCol="0" anchor="ctr"/>
           <a:lstStyle/>
           <a:p>
-            <a:pPr indent="0" marL="0">
+            <a:pPr marL="0" indent="0">
               <a:buNone/>
             </a:pPr>
             <a:r>
@@ -7074,15 +7088,20 @@
             <a:ext cx="2560320" cy="658368"/>
           </a:xfrm>
           <a:prstGeom prst="rect">
-            <a:avLst>
-              <a:gd name="adj" fmla="val 6944"/>
-            </a:avLst>
+            <a:avLst/>
           </a:prstGeom>
           <a:solidFill>
             <a:srgbClr val="152238"/>
           </a:solidFill>
           <a:ln/>
         </p:spPr>
+        <p:txBody>
+          <a:bodyPr/>
+          <a:lstStyle/>
+          <a:p>
+            <a:endParaRPr lang="zh-CN" altLang="en-US"/>
+          </a:p>
+        </p:txBody>
       </p:sp>
       <p:sp>
         <p:nvSpPr>
@@ -7105,7 +7124,7 @@
           <a:bodyPr wrap="square" lIns="0" tIns="0" rIns="0" bIns="0" rtlCol="0" anchor="ctr"/>
           <a:lstStyle/>
           <a:p>
-            <a:pPr indent="0" marL="0">
+            <a:pPr marL="0" indent="0">
               <a:buNone/>
             </a:pPr>
             <a:r>
@@ -7135,15 +7154,20 @@
             <a:ext cx="2560320" cy="658368"/>
           </a:xfrm>
           <a:prstGeom prst="rect">
-            <a:avLst>
-              <a:gd name="adj" fmla="val 6944"/>
-            </a:avLst>
+            <a:avLst/>
           </a:prstGeom>
           <a:solidFill>
             <a:srgbClr val="152238"/>
           </a:solidFill>
           <a:ln/>
         </p:spPr>
+        <p:txBody>
+          <a:bodyPr/>
+          <a:lstStyle/>
+          <a:p>
+            <a:endParaRPr lang="zh-CN" altLang="en-US"/>
+          </a:p>
+        </p:txBody>
       </p:sp>
       <p:sp>
         <p:nvSpPr>
@@ -7166,7 +7190,7 @@
           <a:bodyPr wrap="square" lIns="0" tIns="0" rIns="0" bIns="0" rtlCol="0" anchor="ctr"/>
           <a:lstStyle/>
           <a:p>
-            <a:pPr indent="0" marL="0">
+            <a:pPr marL="0" indent="0">
               <a:buNone/>
             </a:pPr>
             <a:r>
@@ -7196,15 +7220,20 @@
             <a:ext cx="2560320" cy="658368"/>
           </a:xfrm>
           <a:prstGeom prst="rect">
-            <a:avLst>
-              <a:gd name="adj" fmla="val 6944"/>
-            </a:avLst>
+            <a:avLst/>
           </a:prstGeom>
           <a:solidFill>
             <a:srgbClr val="C9A96E"/>
           </a:solidFill>
           <a:ln/>
         </p:spPr>
+        <p:txBody>
+          <a:bodyPr/>
+          <a:lstStyle/>
+          <a:p>
+            <a:endParaRPr lang="zh-CN" altLang="en-US"/>
+          </a:p>
+        </p:txBody>
       </p:sp>
       <p:sp>
         <p:nvSpPr>
@@ -7227,7 +7256,7 @@
           <a:bodyPr wrap="square" lIns="0" tIns="0" rIns="0" bIns="0" rtlCol="0" anchor="ctr"/>
           <a:lstStyle/>
           <a:p>
-            <a:pPr indent="0" marL="0">
+            <a:pPr marL="0" indent="0">
               <a:buNone/>
             </a:pPr>
             <a:r>
@@ -7257,15 +7286,20 @@
             <a:ext cx="2560320" cy="658368"/>
           </a:xfrm>
           <a:prstGeom prst="rect">
-            <a:avLst>
-              <a:gd name="adj" fmla="val 6944"/>
-            </a:avLst>
+            <a:avLst/>
           </a:prstGeom>
           <a:solidFill>
             <a:srgbClr val="152238"/>
           </a:solidFill>
           <a:ln/>
         </p:spPr>
+        <p:txBody>
+          <a:bodyPr/>
+          <a:lstStyle/>
+          <a:p>
+            <a:endParaRPr lang="zh-CN" altLang="en-US"/>
+          </a:p>
+        </p:txBody>
       </p:sp>
       <p:sp>
         <p:nvSpPr>
@@ -7288,7 +7322,7 @@
           <a:bodyPr wrap="square" lIns="0" tIns="0" rIns="0" bIns="0" rtlCol="0" anchor="ctr"/>
           <a:lstStyle/>
           <a:p>
-            <a:pPr indent="0" marL="0">
+            <a:pPr marL="0" indent="0">
               <a:buNone/>
             </a:pPr>
             <a:r>
@@ -7318,15 +7352,20 @@
             <a:ext cx="2560320" cy="658368"/>
           </a:xfrm>
           <a:prstGeom prst="rect">
-            <a:avLst>
-              <a:gd name="adj" fmla="val 6944"/>
-            </a:avLst>
+            <a:avLst/>
           </a:prstGeom>
           <a:solidFill>
             <a:srgbClr val="152238"/>
           </a:solidFill>
           <a:ln/>
         </p:spPr>
+        <p:txBody>
+          <a:bodyPr/>
+          <a:lstStyle/>
+          <a:p>
+            <a:endParaRPr lang="zh-CN" altLang="en-US"/>
+          </a:p>
+        </p:txBody>
       </p:sp>
       <p:sp>
         <p:nvSpPr>
@@ -7349,7 +7388,7 @@
           <a:bodyPr wrap="square" lIns="0" tIns="0" rIns="0" bIns="0" rtlCol="0" anchor="ctr"/>
           <a:lstStyle/>
           <a:p>
-            <a:pPr indent="0" marL="0">
+            <a:pPr marL="0" indent="0">
               <a:buNone/>
             </a:pPr>
             <a:r>
@@ -7379,15 +7418,20 @@
             <a:ext cx="2560320" cy="658368"/>
           </a:xfrm>
           <a:prstGeom prst="rect">
-            <a:avLst>
-              <a:gd name="adj" fmla="val 6944"/>
-            </a:avLst>
+            <a:avLst/>
           </a:prstGeom>
           <a:solidFill>
             <a:srgbClr val="C9A96E"/>
           </a:solidFill>
           <a:ln/>
         </p:spPr>
+        <p:txBody>
+          <a:bodyPr/>
+          <a:lstStyle/>
+          <a:p>
+            <a:endParaRPr lang="zh-CN" altLang="en-US"/>
+          </a:p>
+        </p:txBody>
       </p:sp>
       <p:sp>
         <p:nvSpPr>
@@ -7410,7 +7454,7 @@
           <a:bodyPr wrap="square" lIns="0" tIns="0" rIns="0" bIns="0" rtlCol="0" anchor="ctr"/>
           <a:lstStyle/>
           <a:p>
-            <a:pPr indent="0" marL="0">
+            <a:pPr marL="0" indent="0">
               <a:buNone/>
             </a:pPr>
             <a:r>
@@ -7440,15 +7484,20 @@
             <a:ext cx="2560320" cy="658368"/>
           </a:xfrm>
           <a:prstGeom prst="rect">
-            <a:avLst>
-              <a:gd name="adj" fmla="val 6944"/>
-            </a:avLst>
+            <a:avLst/>
           </a:prstGeom>
           <a:solidFill>
             <a:srgbClr val="152238"/>
           </a:solidFill>
           <a:ln/>
         </p:spPr>
+        <p:txBody>
+          <a:bodyPr/>
+          <a:lstStyle/>
+          <a:p>
+            <a:endParaRPr lang="zh-CN" altLang="en-US"/>
+          </a:p>
+        </p:txBody>
       </p:sp>
       <p:sp>
         <p:nvSpPr>
@@ -7471,7 +7520,7 @@
           <a:bodyPr wrap="square" lIns="0" tIns="0" rIns="0" bIns="0" rtlCol="0" anchor="ctr"/>
           <a:lstStyle/>
           <a:p>
-            <a:pPr indent="0" marL="0">
+            <a:pPr marL="0" indent="0">
               <a:buNone/>
             </a:pPr>
             <a:r>
@@ -7501,15 +7550,20 @@
             <a:ext cx="2560320" cy="658368"/>
           </a:xfrm>
           <a:prstGeom prst="rect">
-            <a:avLst>
-              <a:gd name="adj" fmla="val 6944"/>
-            </a:avLst>
+            <a:avLst/>
           </a:prstGeom>
           <a:solidFill>
             <a:srgbClr val="152238"/>
           </a:solidFill>
           <a:ln/>
         </p:spPr>
+        <p:txBody>
+          <a:bodyPr/>
+          <a:lstStyle/>
+          <a:p>
+            <a:endParaRPr lang="zh-CN" altLang="en-US"/>
+          </a:p>
+        </p:txBody>
       </p:sp>
       <p:sp>
         <p:nvSpPr>
@@ -7532,7 +7586,7 @@
           <a:bodyPr wrap="square" lIns="0" tIns="0" rIns="0" bIns="0" rtlCol="0" anchor="ctr"/>
           <a:lstStyle/>
           <a:p>
-            <a:pPr indent="0" marL="0">
+            <a:pPr marL="0" indent="0">
               <a:buNone/>
             </a:pPr>
             <a:r>
@@ -7558,7 +7612,7 @@
         </p:nvSpPr>
         <p:spPr>
           <a:xfrm>
-            <a:off x="548640" y="4160520"/>
+            <a:off x="548640" y="3994501"/>
             <a:ext cx="8046720" cy="0"/>
           </a:xfrm>
           <a:prstGeom prst="line">
@@ -7572,6 +7626,13 @@
             <a:prstDash val="solid"/>
           </a:ln>
         </p:spPr>
+        <p:txBody>
+          <a:bodyPr/>
+          <a:lstStyle/>
+          <a:p>
+            <a:endParaRPr lang="zh-CN" altLang="en-US"/>
+          </a:p>
+        </p:txBody>
       </p:sp>
       <p:sp>
         <p:nvSpPr>
@@ -7581,7 +7642,7 @@
         </p:nvSpPr>
         <p:spPr>
           <a:xfrm>
-            <a:off x="548640" y="4297680"/>
+            <a:off x="548640" y="4131661"/>
             <a:ext cx="2560320" cy="292608"/>
           </a:xfrm>
           <a:prstGeom prst="rect">
@@ -7594,11 +7655,11 @@
           <a:bodyPr wrap="square" lIns="0" tIns="0" rIns="0" bIns="0" rtlCol="0" anchor="ctr"/>
           <a:lstStyle/>
           <a:p>
-            <a:pPr indent="0" marL="0">
-              <a:buNone/>
-            </a:pPr>
-            <a:r>
-              <a:rPr lang="en-US" sz="1600" spc="100" kern="0" dirty="0">
+            <a:pPr marL="0" indent="0">
+              <a:buNone/>
+            </a:pPr>
+            <a:r>
+              <a:rPr lang="en-US" sz="1600" kern="0" spc="100" dirty="0">
                 <a:solidFill>
                   <a:srgbClr val="C9A96E"/>
                 </a:solidFill>
@@ -7620,7 +7681,7 @@
         </p:nvSpPr>
         <p:spPr>
           <a:xfrm>
-            <a:off x="548640" y="4572000"/>
+            <a:off x="548640" y="4405981"/>
             <a:ext cx="2560320" cy="201168"/>
           </a:xfrm>
           <a:prstGeom prst="rect">
@@ -7633,7 +7694,7 @@
           <a:bodyPr wrap="square" lIns="0" tIns="0" rIns="0" bIns="0" rtlCol="0" anchor="ctr"/>
           <a:lstStyle/>
           <a:p>
-            <a:pPr indent="0" marL="0">
+            <a:pPr marL="0" indent="0">
               <a:buNone/>
             </a:pPr>
             <a:r>
@@ -7659,7 +7720,7 @@
         </p:nvSpPr>
         <p:spPr>
           <a:xfrm>
-            <a:off x="548640" y="4754880"/>
+            <a:off x="548640" y="4680302"/>
             <a:ext cx="2560320" cy="164592"/>
           </a:xfrm>
           <a:prstGeom prst="rect">
@@ -7672,7 +7733,7 @@
           <a:bodyPr wrap="square" lIns="0" tIns="0" rIns="0" bIns="0" rtlCol="0" anchor="ctr"/>
           <a:lstStyle/>
           <a:p>
-            <a:pPr indent="0" marL="0">
+            <a:pPr marL="0" indent="0">
               <a:buNone/>
             </a:pPr>
             <a:r>
@@ -7698,7 +7759,7 @@
         </p:nvSpPr>
         <p:spPr>
           <a:xfrm>
-            <a:off x="3337560" y="4297680"/>
+            <a:off x="3337560" y="4131661"/>
             <a:ext cx="2560320" cy="292608"/>
           </a:xfrm>
           <a:prstGeom prst="rect">
@@ -7711,11 +7772,11 @@
           <a:bodyPr wrap="square" lIns="0" tIns="0" rIns="0" bIns="0" rtlCol="0" anchor="ctr"/>
           <a:lstStyle/>
           <a:p>
-            <a:pPr indent="0" marL="0">
-              <a:buNone/>
-            </a:pPr>
-            <a:r>
-              <a:rPr lang="en-US" sz="1600" spc="100" kern="0" dirty="0">
+            <a:pPr marL="0" indent="0">
+              <a:buNone/>
+            </a:pPr>
+            <a:r>
+              <a:rPr lang="en-US" sz="1600" kern="0" spc="100" dirty="0">
                 <a:solidFill>
                   <a:srgbClr val="C9A96E"/>
                 </a:solidFill>
@@ -7737,7 +7798,7 @@
         </p:nvSpPr>
         <p:spPr>
           <a:xfrm>
-            <a:off x="3337560" y="4572000"/>
+            <a:off x="3337560" y="4405981"/>
             <a:ext cx="2560320" cy="201168"/>
           </a:xfrm>
           <a:prstGeom prst="rect">
@@ -7750,7 +7811,7 @@
           <a:bodyPr wrap="square" lIns="0" tIns="0" rIns="0" bIns="0" rtlCol="0" anchor="ctr"/>
           <a:lstStyle/>
           <a:p>
-            <a:pPr indent="0" marL="0">
+            <a:pPr marL="0" indent="0">
               <a:buNone/>
             </a:pPr>
             <a:r>
@@ -7776,7 +7837,7 @@
         </p:nvSpPr>
         <p:spPr>
           <a:xfrm>
-            <a:off x="3337560" y="4754880"/>
+            <a:off x="3337560" y="4680302"/>
             <a:ext cx="2560320" cy="164592"/>
           </a:xfrm>
           <a:prstGeom prst="rect">
@@ -7789,7 +7850,7 @@
           <a:bodyPr wrap="square" lIns="0" tIns="0" rIns="0" bIns="0" rtlCol="0" anchor="ctr"/>
           <a:lstStyle/>
           <a:p>
-            <a:pPr indent="0" marL="0">
+            <a:pPr marL="0" indent="0">
               <a:buNone/>
             </a:pPr>
             <a:r>
@@ -7815,7 +7876,7 @@
         </p:nvSpPr>
         <p:spPr>
           <a:xfrm>
-            <a:off x="6126480" y="4297680"/>
+            <a:off x="6126480" y="4131661"/>
             <a:ext cx="2560320" cy="292608"/>
           </a:xfrm>
           <a:prstGeom prst="rect">
@@ -7828,11 +7889,11 @@
           <a:bodyPr wrap="square" lIns="0" tIns="0" rIns="0" bIns="0" rtlCol="0" anchor="ctr"/>
           <a:lstStyle/>
           <a:p>
-            <a:pPr indent="0" marL="0">
-              <a:buNone/>
-            </a:pPr>
-            <a:r>
-              <a:rPr lang="en-US" sz="1600" spc="100" kern="0" dirty="0">
+            <a:pPr marL="0" indent="0">
+              <a:buNone/>
+            </a:pPr>
+            <a:r>
+              <a:rPr lang="en-US" sz="1600" kern="0" spc="100" dirty="0">
                 <a:solidFill>
                   <a:srgbClr val="C9A96E"/>
                 </a:solidFill>
@@ -7854,7 +7915,7 @@
         </p:nvSpPr>
         <p:spPr>
           <a:xfrm>
-            <a:off x="6126480" y="4572000"/>
+            <a:off x="6126480" y="4405981"/>
             <a:ext cx="2560320" cy="201168"/>
           </a:xfrm>
           <a:prstGeom prst="rect">
@@ -7867,7 +7928,7 @@
           <a:bodyPr wrap="square" lIns="0" tIns="0" rIns="0" bIns="0" rtlCol="0" anchor="ctr"/>
           <a:lstStyle/>
           <a:p>
-            <a:pPr indent="0" marL="0">
+            <a:pPr marL="0" indent="0">
               <a:buNone/>
             </a:pPr>
             <a:r>
@@ -7893,7 +7954,7 @@
         </p:nvSpPr>
         <p:spPr>
           <a:xfrm>
-            <a:off x="6126480" y="4754880"/>
+            <a:off x="6126480" y="4698589"/>
             <a:ext cx="2560320" cy="164592"/>
           </a:xfrm>
           <a:prstGeom prst="rect">
@@ -7906,7 +7967,7 @@
           <a:bodyPr wrap="square" lIns="0" tIns="0" rIns="0" bIns="0" rtlCol="0" anchor="ctr"/>
           <a:lstStyle/>
           <a:p>
-            <a:pPr indent="0" marL="0">
+            <a:pPr marL="0" indent="0">
               <a:buNone/>
             </a:pPr>
             <a:r>
@@ -7932,7 +7993,7 @@
         </p:nvSpPr>
         <p:spPr>
           <a:xfrm>
-            <a:off x="548640" y="4754880"/>
+            <a:off x="548640" y="4927189"/>
             <a:ext cx="4572000" cy="274320"/>
           </a:xfrm>
           <a:prstGeom prst="rect">
@@ -7945,11 +8006,11 @@
           <a:bodyPr wrap="square" rtlCol="0" anchor="ctr"/>
           <a:lstStyle/>
           <a:p>
-            <a:pPr indent="0" marL="0">
-              <a:buNone/>
-            </a:pPr>
-            <a:r>
-              <a:rPr lang="en-US" sz="800" spc="200" kern="0" dirty="0">
+            <a:pPr marL="0" indent="0">
+              <a:buNone/>
+            </a:pPr>
+            <a:r>
+              <a:rPr lang="en-US" sz="800" kern="0" spc="200" dirty="0">
                 <a:solidFill>
                   <a:srgbClr val="8A95A5"/>
                 </a:solidFill>
@@ -7984,11 +8045,11 @@
           <a:bodyPr wrap="square" rtlCol="0" anchor="ctr"/>
           <a:lstStyle/>
           <a:p>
-            <a:pPr algn="r" indent="0" marL="0">
-              <a:buNone/>
-            </a:pPr>
-            <a:r>
-              <a:rPr lang="en-US" sz="900" spc="300" kern="0" dirty="0">
+            <a:pPr marL="0" indent="0" algn="r">
+              <a:buNone/>
+            </a:pPr>
+            <a:r>
+              <a:rPr lang="en-US" sz="900" kern="0" spc="300" dirty="0">
                 <a:solidFill>
                   <a:srgbClr val="C9A96E"/>
                 </a:solidFill>
@@ -8010,7 +8071,7 @@
         </p:nvSpPr>
         <p:spPr>
           <a:xfrm>
-            <a:off x="548640" y="4709160"/>
+            <a:off x="548640" y="4543141"/>
             <a:ext cx="8046720" cy="0"/>
           </a:xfrm>
           <a:prstGeom prst="line">
@@ -8024,6 +8085,13 @@
             <a:prstDash val="solid"/>
           </a:ln>
         </p:spPr>
+        <p:txBody>
+          <a:bodyPr/>
+          <a:lstStyle/>
+          <a:p>
+            <a:endParaRPr lang="zh-CN" altLang="en-US"/>
+          </a:p>
+        </p:txBody>
       </p:sp>
     </p:spTree>
   </p:cSld>
@@ -8041,6 +8109,7 @@
         <a:solidFill>
           <a:srgbClr val="0D1B2A"/>
         </a:solidFill>
+        <a:effectLst/>
       </p:bgPr>
     </p:bg>
     <p:spTree>
@@ -8078,7 +8147,7 @@
           <a:bodyPr wrap="square" lIns="0" tIns="0" rIns="0" bIns="0" rtlCol="0" anchor="ctr"/>
           <a:lstStyle/>
           <a:p>
-            <a:pPr indent="0" marL="0">
+            <a:pPr marL="0" indent="0">
               <a:buNone/>
             </a:pPr>
             <a:r>
@@ -8118,6 +8187,13 @@
             <a:prstDash val="solid"/>
           </a:ln>
         </p:spPr>
+        <p:txBody>
+          <a:bodyPr/>
+          <a:lstStyle/>
+          <a:p>
+            <a:endParaRPr lang="zh-CN" altLang="en-US"/>
+          </a:p>
+        </p:txBody>
       </p:sp>
       <p:sp>
         <p:nvSpPr>
@@ -8131,15 +8207,20 @@
             <a:ext cx="8046720" cy="1051560"/>
           </a:xfrm>
           <a:prstGeom prst="rect">
-            <a:avLst>
-              <a:gd name="adj" fmla="val 4348"/>
-            </a:avLst>
+            <a:avLst/>
           </a:prstGeom>
           <a:solidFill>
             <a:srgbClr val="C9A96E"/>
           </a:solidFill>
           <a:ln/>
         </p:spPr>
+        <p:txBody>
+          <a:bodyPr/>
+          <a:lstStyle/>
+          <a:p>
+            <a:endParaRPr lang="zh-CN" altLang="en-US"/>
+          </a:p>
+        </p:txBody>
       </p:sp>
       <p:sp>
         <p:nvSpPr>
@@ -8162,7 +8243,7 @@
           <a:bodyPr wrap="square" lIns="0" tIns="0" rIns="0" bIns="0" rtlCol="0" anchor="ctr"/>
           <a:lstStyle/>
           <a:p>
-            <a:pPr indent="0" marL="0">
+            <a:pPr marL="0" indent="0">
               <a:buNone/>
             </a:pPr>
             <a:r>
@@ -8352,15 +8433,20 @@
             <a:ext cx="8046720" cy="1051560"/>
           </a:xfrm>
           <a:prstGeom prst="rect">
-            <a:avLst>
-              <a:gd name="adj" fmla="val 4348"/>
-            </a:avLst>
+            <a:avLst/>
           </a:prstGeom>
           <a:solidFill>
             <a:srgbClr val="152238"/>
           </a:solidFill>
           <a:ln/>
         </p:spPr>
+        <p:txBody>
+          <a:bodyPr/>
+          <a:lstStyle/>
+          <a:p>
+            <a:endParaRPr lang="zh-CN" altLang="en-US"/>
+          </a:p>
+        </p:txBody>
       </p:sp>
       <p:sp>
         <p:nvSpPr>
@@ -8383,7 +8469,7 @@
           <a:bodyPr wrap="square" lIns="0" tIns="0" rIns="0" bIns="0" rtlCol="0" anchor="ctr"/>
           <a:lstStyle/>
           <a:p>
-            <a:pPr indent="0" marL="0">
+            <a:pPr marL="0" indent="0">
               <a:buNone/>
             </a:pPr>
             <a:r>
@@ -8573,15 +8659,20 @@
             <a:ext cx="8046720" cy="1051560"/>
           </a:xfrm>
           <a:prstGeom prst="rect">
-            <a:avLst>
-              <a:gd name="adj" fmla="val 4348"/>
-            </a:avLst>
+            <a:avLst/>
           </a:prstGeom>
           <a:solidFill>
             <a:srgbClr val="152238"/>
           </a:solidFill>
           <a:ln/>
         </p:spPr>
+        <p:txBody>
+          <a:bodyPr/>
+          <a:lstStyle/>
+          <a:p>
+            <a:endParaRPr lang="zh-CN" altLang="en-US"/>
+          </a:p>
+        </p:txBody>
       </p:sp>
       <p:sp>
         <p:nvSpPr>
@@ -8604,7 +8695,7 @@
           <a:bodyPr wrap="square" lIns="0" tIns="0" rIns="0" bIns="0" rtlCol="0" anchor="ctr"/>
           <a:lstStyle/>
           <a:p>
-            <a:pPr indent="0" marL="0">
+            <a:pPr marL="0" indent="0">
               <a:buNone/>
             </a:pPr>
             <a:r>
@@ -8803,11 +8894,11 @@
           <a:bodyPr wrap="square" rtlCol="0" anchor="ctr"/>
           <a:lstStyle/>
           <a:p>
-            <a:pPr indent="0" marL="0">
-              <a:buNone/>
-            </a:pPr>
-            <a:r>
-              <a:rPr lang="en-US" sz="800" spc="200" kern="0" dirty="0">
+            <a:pPr marL="0" indent="0">
+              <a:buNone/>
+            </a:pPr>
+            <a:r>
+              <a:rPr lang="en-US" sz="800" kern="0" spc="200" dirty="0">
                 <a:solidFill>
                   <a:srgbClr val="8A95A5"/>
                 </a:solidFill>
@@ -8842,11 +8933,11 @@
           <a:bodyPr wrap="square" rtlCol="0" anchor="ctr"/>
           <a:lstStyle/>
           <a:p>
-            <a:pPr algn="r" indent="0" marL="0">
-              <a:buNone/>
-            </a:pPr>
-            <a:r>
-              <a:rPr lang="en-US" sz="900" spc="300" kern="0" dirty="0">
+            <a:pPr marL="0" indent="0" algn="r">
+              <a:buNone/>
+            </a:pPr>
+            <a:r>
+              <a:rPr lang="en-US" sz="900" kern="0" spc="300" dirty="0">
                 <a:solidFill>
                   <a:srgbClr val="C9A96E"/>
                 </a:solidFill>
@@ -8882,6 +8973,13 @@
             <a:prstDash val="solid"/>
           </a:ln>
         </p:spPr>
+        <p:txBody>
+          <a:bodyPr/>
+          <a:lstStyle/>
+          <a:p>
+            <a:endParaRPr lang="zh-CN" altLang="en-US"/>
+          </a:p>
+        </p:txBody>
       </p:sp>
     </p:spTree>
   </p:cSld>
@@ -8899,6 +8997,7 @@
         <a:solidFill>
           <a:srgbClr val="0D1B2A"/>
         </a:solidFill>
+        <a:effectLst/>
       </p:bgPr>
     </p:bg>
     <p:spTree>
@@ -8936,7 +9035,7 @@
           <a:bodyPr wrap="square" lIns="0" tIns="0" rIns="0" bIns="0" rtlCol="0" anchor="ctr"/>
           <a:lstStyle/>
           <a:p>
-            <a:pPr indent="0" marL="0">
+            <a:pPr marL="0" indent="0">
               <a:buNone/>
             </a:pPr>
             <a:r>
@@ -8976,6 +9075,13 @@
             <a:prstDash val="solid"/>
           </a:ln>
         </p:spPr>
+        <p:txBody>
+          <a:bodyPr/>
+          <a:lstStyle/>
+          <a:p>
+            <a:endParaRPr lang="zh-CN" altLang="en-US"/>
+          </a:p>
+        </p:txBody>
       </p:sp>
       <p:sp>
         <p:nvSpPr>
@@ -8989,15 +9095,20 @@
             <a:ext cx="8046720" cy="1005840"/>
           </a:xfrm>
           <a:prstGeom prst="rect">
-            <a:avLst>
-              <a:gd name="adj" fmla="val 4545"/>
-            </a:avLst>
+            <a:avLst/>
           </a:prstGeom>
           <a:solidFill>
             <a:srgbClr val="152238"/>
           </a:solidFill>
           <a:ln/>
         </p:spPr>
+        <p:txBody>
+          <a:bodyPr/>
+          <a:lstStyle/>
+          <a:p>
+            <a:endParaRPr lang="zh-CN" altLang="en-US"/>
+          </a:p>
+        </p:txBody>
       </p:sp>
       <p:sp>
         <p:nvSpPr>
@@ -9018,6 +9129,13 @@
           </a:solidFill>
           <a:ln/>
         </p:spPr>
+        <p:txBody>
+          <a:bodyPr/>
+          <a:lstStyle/>
+          <a:p>
+            <a:endParaRPr lang="zh-CN" altLang="en-US"/>
+          </a:p>
+        </p:txBody>
       </p:sp>
       <p:sp>
         <p:nvSpPr>
@@ -9040,7 +9158,7 @@
           <a:bodyPr wrap="square" lIns="0" tIns="0" rIns="0" bIns="0" rtlCol="0" anchor="ctr"/>
           <a:lstStyle/>
           <a:p>
-            <a:pPr indent="0" marL="0">
+            <a:pPr marL="0" indent="0">
               <a:buNone/>
             </a:pPr>
             <a:r>
@@ -9079,7 +9197,7 @@
           <a:bodyPr wrap="square" lIns="0" tIns="0" rIns="0" bIns="0" rtlCol="0" anchor="ctr"/>
           <a:lstStyle/>
           <a:p>
-            <a:pPr indent="0" marL="0">
+            <a:pPr marL="0" indent="0">
               <a:buNone/>
             </a:pPr>
             <a:r>
@@ -9118,7 +9236,7 @@
           <a:bodyPr wrap="square" lIns="0" tIns="0" rIns="0" bIns="0" rtlCol="0" anchor="ctr"/>
           <a:lstStyle/>
           <a:p>
-            <a:pPr indent="0" marL="0">
+            <a:pPr marL="0" indent="0">
               <a:lnSpc>
                 <a:spcPct val="150000"/>
               </a:lnSpc>
@@ -9138,7 +9256,7 @@
             <a:endParaRPr lang="en-US" sz="900" dirty="0"/>
           </a:p>
           <a:p>
-            <a:pPr indent="0" marL="0">
+            <a:pPr marL="0" indent="0">
               <a:lnSpc>
                 <a:spcPct val="150000"/>
               </a:lnSpc>
@@ -9158,7 +9276,7 @@
             <a:endParaRPr lang="en-US" sz="900" dirty="0"/>
           </a:p>
           <a:p>
-            <a:pPr indent="0" marL="0">
+            <a:pPr marL="0" indent="0">
               <a:lnSpc>
                 <a:spcPct val="150000"/>
               </a:lnSpc>
@@ -9191,15 +9309,20 @@
             <a:ext cx="8046720" cy="1005840"/>
           </a:xfrm>
           <a:prstGeom prst="rect">
-            <a:avLst>
-              <a:gd name="adj" fmla="val 4545"/>
-            </a:avLst>
+            <a:avLst/>
           </a:prstGeom>
           <a:solidFill>
             <a:srgbClr val="152238"/>
           </a:solidFill>
           <a:ln/>
         </p:spPr>
+        <p:txBody>
+          <a:bodyPr/>
+          <a:lstStyle/>
+          <a:p>
+            <a:endParaRPr lang="zh-CN" altLang="en-US"/>
+          </a:p>
+        </p:txBody>
       </p:sp>
       <p:sp>
         <p:nvSpPr>
@@ -9220,6 +9343,13 @@
           </a:solidFill>
           <a:ln/>
         </p:spPr>
+        <p:txBody>
+          <a:bodyPr/>
+          <a:lstStyle/>
+          <a:p>
+            <a:endParaRPr lang="zh-CN" altLang="en-US"/>
+          </a:p>
+        </p:txBody>
       </p:sp>
       <p:sp>
         <p:nvSpPr>
@@ -9242,7 +9372,7 @@
           <a:bodyPr wrap="square" lIns="0" tIns="0" rIns="0" bIns="0" rtlCol="0" anchor="ctr"/>
           <a:lstStyle/>
           <a:p>
-            <a:pPr indent="0" marL="0">
+            <a:pPr marL="0" indent="0">
               <a:buNone/>
             </a:pPr>
             <a:r>
@@ -9281,7 +9411,7 @@
           <a:bodyPr wrap="square" lIns="0" tIns="0" rIns="0" bIns="0" rtlCol="0" anchor="ctr"/>
           <a:lstStyle/>
           <a:p>
-            <a:pPr indent="0" marL="0">
+            <a:pPr marL="0" indent="0">
               <a:buNone/>
             </a:pPr>
             <a:r>
@@ -9320,7 +9450,7 @@
           <a:bodyPr wrap="square" lIns="0" tIns="0" rIns="0" bIns="0" rtlCol="0" anchor="ctr"/>
           <a:lstStyle/>
           <a:p>
-            <a:pPr indent="0" marL="0">
+            <a:pPr marL="0" indent="0">
               <a:lnSpc>
                 <a:spcPct val="150000"/>
               </a:lnSpc>
@@ -9340,7 +9470,7 @@
             <a:endParaRPr lang="en-US" sz="900" dirty="0"/>
           </a:p>
           <a:p>
-            <a:pPr indent="0" marL="0">
+            <a:pPr marL="0" indent="0">
               <a:lnSpc>
                 <a:spcPct val="150000"/>
               </a:lnSpc>
@@ -9373,15 +9503,20 @@
             <a:ext cx="8046720" cy="1005840"/>
           </a:xfrm>
           <a:prstGeom prst="rect">
-            <a:avLst>
-              <a:gd name="adj" fmla="val 4545"/>
-            </a:avLst>
+            <a:avLst/>
           </a:prstGeom>
           <a:solidFill>
             <a:srgbClr val="152238"/>
           </a:solidFill>
           <a:ln/>
         </p:spPr>
+        <p:txBody>
+          <a:bodyPr/>
+          <a:lstStyle/>
+          <a:p>
+            <a:endParaRPr lang="zh-CN" altLang="en-US"/>
+          </a:p>
+        </p:txBody>
       </p:sp>
       <p:sp>
         <p:nvSpPr>
@@ -9402,6 +9537,13 @@
           </a:solidFill>
           <a:ln/>
         </p:spPr>
+        <p:txBody>
+          <a:bodyPr/>
+          <a:lstStyle/>
+          <a:p>
+            <a:endParaRPr lang="zh-CN" altLang="en-US"/>
+          </a:p>
+        </p:txBody>
       </p:sp>
       <p:sp>
         <p:nvSpPr>
@@ -9424,7 +9566,7 @@
           <a:bodyPr wrap="square" lIns="0" tIns="0" rIns="0" bIns="0" rtlCol="0" anchor="ctr"/>
           <a:lstStyle/>
           <a:p>
-            <a:pPr indent="0" marL="0">
+            <a:pPr marL="0" indent="0">
               <a:buNone/>
             </a:pPr>
             <a:r>
@@ -9463,7 +9605,7 @@
           <a:bodyPr wrap="square" lIns="0" tIns="0" rIns="0" bIns="0" rtlCol="0" anchor="ctr"/>
           <a:lstStyle/>
           <a:p>
-            <a:pPr indent="0" marL="0">
+            <a:pPr marL="0" indent="0">
               <a:buNone/>
             </a:pPr>
             <a:r>
@@ -9502,7 +9644,7 @@
           <a:bodyPr wrap="square" lIns="0" tIns="0" rIns="0" bIns="0" rtlCol="0" anchor="ctr"/>
           <a:lstStyle/>
           <a:p>
-            <a:pPr indent="0" marL="0">
+            <a:pPr marL="0" indent="0">
               <a:lnSpc>
                 <a:spcPct val="150000"/>
               </a:lnSpc>
@@ -9522,7 +9664,7 @@
             <a:endParaRPr lang="en-US" sz="900" dirty="0"/>
           </a:p>
           <a:p>
-            <a:pPr indent="0" marL="0">
+            <a:pPr marL="0" indent="0">
               <a:lnSpc>
                 <a:spcPct val="150000"/>
               </a:lnSpc>
@@ -9564,11 +9706,11 @@
           <a:bodyPr wrap="square" rtlCol="0" anchor="ctr"/>
           <a:lstStyle/>
           <a:p>
-            <a:pPr indent="0" marL="0">
-              <a:buNone/>
-            </a:pPr>
-            <a:r>
-              <a:rPr lang="en-US" sz="800" spc="200" kern="0" dirty="0">
+            <a:pPr marL="0" indent="0">
+              <a:buNone/>
+            </a:pPr>
+            <a:r>
+              <a:rPr lang="en-US" sz="800" kern="0" spc="200" dirty="0">
                 <a:solidFill>
                   <a:srgbClr val="8A95A5"/>
                 </a:solidFill>
@@ -9603,11 +9745,11 @@
           <a:bodyPr wrap="square" rtlCol="0" anchor="ctr"/>
           <a:lstStyle/>
           <a:p>
-            <a:pPr algn="r" indent="0" marL="0">
-              <a:buNone/>
-            </a:pPr>
-            <a:r>
-              <a:rPr lang="en-US" sz="900" spc="300" kern="0" dirty="0">
+            <a:pPr marL="0" indent="0" algn="r">
+              <a:buNone/>
+            </a:pPr>
+            <a:r>
+              <a:rPr lang="en-US" sz="900" kern="0" spc="300" dirty="0">
                 <a:solidFill>
                   <a:srgbClr val="C9A96E"/>
                 </a:solidFill>
@@ -9643,6 +9785,13 @@
             <a:prstDash val="solid"/>
           </a:ln>
         </p:spPr>
+        <p:txBody>
+          <a:bodyPr/>
+          <a:lstStyle/>
+          <a:p>
+            <a:endParaRPr lang="zh-CN" altLang="en-US"/>
+          </a:p>
+        </p:txBody>
       </p:sp>
     </p:spTree>
   </p:cSld>
@@ -9660,6 +9809,7 @@
         <a:solidFill>
           <a:srgbClr val="0D1B2A"/>
         </a:solidFill>
+        <a:effectLst/>
       </p:bgPr>
     </p:bg>
     <p:spTree>
@@ -9695,6 +9845,13 @@
           </a:solidFill>
           <a:ln/>
         </p:spPr>
+        <p:txBody>
+          <a:bodyPr/>
+          <a:lstStyle/>
+          <a:p>
+            <a:endParaRPr lang="zh-CN" altLang="en-US"/>
+          </a:p>
+        </p:txBody>
       </p:sp>
       <p:sp>
         <p:nvSpPr>
@@ -9717,11 +9874,11 @@
           <a:bodyPr wrap="square" lIns="0" tIns="0" rIns="0" bIns="0" rtlCol="0" anchor="ctr"/>
           <a:lstStyle/>
           <a:p>
-            <a:pPr indent="0" marL="0">
-              <a:buNone/>
-            </a:pPr>
-            <a:r>
-              <a:rPr lang="en-US" sz="4400" b="1" spc="400" kern="0" dirty="0">
+            <a:pPr marL="0" indent="0">
+              <a:buNone/>
+            </a:pPr>
+            <a:r>
+              <a:rPr lang="en-US" sz="4400" b="1" kern="0" spc="400" dirty="0">
                 <a:solidFill>
                   <a:srgbClr val="E8E4DD"/>
                 </a:solidFill>
@@ -9757,6 +9914,13 @@
             <a:prstDash val="solid"/>
           </a:ln>
         </p:spPr>
+        <p:txBody>
+          <a:bodyPr/>
+          <a:lstStyle/>
+          <a:p>
+            <a:endParaRPr lang="zh-CN" altLang="en-US"/>
+          </a:p>
+        </p:txBody>
       </p:sp>
       <p:sp>
         <p:nvSpPr>
@@ -9779,7 +9943,7 @@
           <a:bodyPr wrap="square" lIns="0" tIns="0" rIns="0" bIns="0" rtlCol="0" anchor="ctr"/>
           <a:lstStyle/>
           <a:p>
-            <a:pPr indent="0" marL="0">
+            <a:pPr marL="0" indent="0">
               <a:lnSpc>
                 <a:spcPct val="180000"/>
               </a:lnSpc>
@@ -9799,7 +9963,7 @@
             <a:endParaRPr lang="en-US" sz="1400" dirty="0"/>
           </a:p>
           <a:p>
-            <a:pPr indent="0" marL="0">
+            <a:pPr marL="0" indent="0">
               <a:lnSpc>
                 <a:spcPct val="180000"/>
               </a:lnSpc>
@@ -9808,7 +9972,7 @@
             <a:endParaRPr lang="en-US" sz="1400" dirty="0"/>
           </a:p>
           <a:p>
-            <a:pPr indent="0" marL="0">
+            <a:pPr marL="0" indent="0">
               <a:lnSpc>
                 <a:spcPct val="180000"/>
               </a:lnSpc>
@@ -9848,6 +10012,13 @@
             <a:prstDash val="solid"/>
           </a:ln>
         </p:spPr>
+        <p:txBody>
+          <a:bodyPr/>
+          <a:lstStyle/>
+          <a:p>
+            <a:endParaRPr lang="zh-CN" altLang="en-US"/>
+          </a:p>
+        </p:txBody>
       </p:sp>
       <p:sp>
         <p:nvSpPr>
@@ -9870,11 +10041,11 @@
           <a:bodyPr wrap="square" lIns="0" tIns="0" rIns="0" bIns="0" rtlCol="0" anchor="ctr"/>
           <a:lstStyle/>
           <a:p>
-            <a:pPr indent="0" marL="0">
-              <a:buNone/>
-            </a:pPr>
-            <a:r>
-              <a:rPr lang="en-US" sz="900" spc="300" kern="0" dirty="0">
+            <a:pPr marL="0" indent="0">
+              <a:buNone/>
+            </a:pPr>
+            <a:r>
+              <a:rPr lang="en-US" sz="900" kern="0" spc="300" dirty="0">
                 <a:solidFill>
                   <a:srgbClr val="8A95A5"/>
                 </a:solidFill>
@@ -10189,4 +10360,319 @@
     </a:ext>
   </a:extLst>
 </a:theme>
+</file>
+
+<file path=ppt/theme/theme2.xml><?xml version="1.0" encoding="utf-8"?>
+<a:theme xmlns:a="http://schemas.openxmlformats.org/drawingml/2006/main" name="Office Theme">
+  <a:themeElements>
+    <a:clrScheme name="Office">
+      <a:dk1>
+        <a:sysClr val="windowText" lastClr="000000"/>
+      </a:dk1>
+      <a:lt1>
+        <a:sysClr val="window" lastClr="FFFFFF"/>
+      </a:lt1>
+      <a:dk2>
+        <a:srgbClr val="0E2841"/>
+      </a:dk2>
+      <a:lt2>
+        <a:srgbClr val="E8E8E8"/>
+      </a:lt2>
+      <a:accent1>
+        <a:srgbClr val="156082"/>
+      </a:accent1>
+      <a:accent2>
+        <a:srgbClr val="E97132"/>
+      </a:accent2>
+      <a:accent3>
+        <a:srgbClr val="196B24"/>
+      </a:accent3>
+      <a:accent4>
+        <a:srgbClr val="0F9ED5"/>
+      </a:accent4>
+      <a:accent5>
+        <a:srgbClr val="A02B93"/>
+      </a:accent5>
+      <a:accent6>
+        <a:srgbClr val="4EA72E"/>
+      </a:accent6>
+      <a:hlink>
+        <a:srgbClr val="467886"/>
+      </a:hlink>
+      <a:folHlink>
+        <a:srgbClr val="96607D"/>
+      </a:folHlink>
+    </a:clrScheme>
+    <a:fontScheme name="Office">
+      <a:majorFont>
+        <a:latin typeface="等线 Light" panose="02110004020202020204"/>
+        <a:ea typeface=""/>
+        <a:cs typeface=""/>
+        <a:font script="Jpan" typeface="游ゴシック Light"/>
+        <a:font script="Hang" typeface="맑은 고딕"/>
+        <a:font script="Hans" typeface="等线 Light"/>
+        <a:font script="Hant" typeface="新細明體"/>
+        <a:font script="Arab" typeface="Times New Roman"/>
+        <a:font script="Hebr" typeface="Times New Roman"/>
+        <a:font script="Thai" typeface="Angsana New"/>
+        <a:font script="Ethi" typeface="Nyala"/>
+        <a:font script="Beng" typeface="Vrinda"/>
+        <a:font script="Gujr" typeface="Shruti"/>
+        <a:font script="Khmr" typeface="MoolBoran"/>
+        <a:font script="Knda" typeface="Tunga"/>
+        <a:font script="Guru" typeface="Raavi"/>
+        <a:font script="Cans" typeface="Euphemia"/>
+        <a:font script="Cher" typeface="Plantagenet Cherokee"/>
+        <a:font script="Yiii" typeface="Microsoft Yi Baiti"/>
+        <a:font script="Tibt" typeface="Microsoft Himalaya"/>
+        <a:font script="Thaa" typeface="MV Boli"/>
+        <a:font script="Deva" typeface="Mangal"/>
+        <a:font script="Telu" typeface="Gautami"/>
+        <a:font script="Taml" typeface="Latha"/>
+        <a:font script="Syrc" typeface="Estrangelo Edessa"/>
+        <a:font script="Orya" typeface="Kalinga"/>
+        <a:font script="Mlym" typeface="Kartika"/>
+        <a:font script="Laoo" typeface="DokChampa"/>
+        <a:font script="Sinh" typeface="Iskoola Pota"/>
+        <a:font script="Mong" typeface="Mongolian Baiti"/>
+        <a:font script="Viet" typeface="Times New Roman"/>
+        <a:font script="Uigh" typeface="Microsoft Uighur"/>
+        <a:font script="Geor" typeface="Sylfaen"/>
+        <a:font script="Armn" typeface="Arial"/>
+        <a:font script="Bugi" typeface="Leelawadee UI"/>
+        <a:font script="Bopo" typeface="Microsoft JhengHei"/>
+        <a:font script="Java" typeface="Javanese Text"/>
+        <a:font script="Lisu" typeface="Segoe UI"/>
+        <a:font script="Mymr" typeface="Myanmar Text"/>
+        <a:font script="Nkoo" typeface="Ebrima"/>
+        <a:font script="Olck" typeface="Nirmala UI"/>
+        <a:font script="Osma" typeface="Ebrima"/>
+        <a:font script="Phag" typeface="Phagspa"/>
+        <a:font script="Syrn" typeface="Estrangelo Edessa"/>
+        <a:font script="Syrj" typeface="Estrangelo Edessa"/>
+        <a:font script="Syre" typeface="Estrangelo Edessa"/>
+        <a:font script="Sora" typeface="Nirmala UI"/>
+        <a:font script="Tale" typeface="Microsoft Tai Le"/>
+        <a:font script="Talu" typeface="Microsoft New Tai Lue"/>
+        <a:font script="Tfng" typeface="Ebrima"/>
+      </a:majorFont>
+      <a:minorFont>
+        <a:latin typeface="等线" panose="02110004020202020204"/>
+        <a:ea typeface=""/>
+        <a:cs typeface=""/>
+        <a:font script="Jpan" typeface="游ゴシック"/>
+        <a:font script="Hang" typeface="맑은 고딕"/>
+        <a:font script="Hans" typeface="等线"/>
+        <a:font script="Hant" typeface="新細明體"/>
+        <a:font script="Arab" typeface="Arial"/>
+        <a:font script="Hebr" typeface="Arial"/>
+        <a:font script="Thai" typeface="Cordia New"/>
+        <a:font script="Ethi" typeface="Nyala"/>
+        <a:font script="Beng" typeface="Vrinda"/>
+        <a:font script="Gujr" typeface="Shruti"/>
+        <a:font script="Khmr" typeface="DaunPenh"/>
+        <a:font script="Knda" typeface="Tunga"/>
+        <a:font script="Guru" typeface="Raavi"/>
+        <a:font script="Cans" typeface="Euphemia"/>
+        <a:font script="Cher" typeface="Plantagenet Cherokee"/>
+        <a:font script="Yiii" typeface="Microsoft Yi Baiti"/>
+        <a:font script="Tibt" typeface="Microsoft Himalaya"/>
+        <a:font script="Thaa" typeface="MV Boli"/>
+        <a:font script="Deva" typeface="Mangal"/>
+        <a:font script="Telu" typeface="Gautami"/>
+        <a:font script="Taml" typeface="Latha"/>
+        <a:font script="Syrc" typeface="Estrangelo Edessa"/>
+        <a:font script="Orya" typeface="Kalinga"/>
+        <a:font script="Mlym" typeface="Kartika"/>
+        <a:font script="Laoo" typeface="DokChampa"/>
+        <a:font script="Sinh" typeface="Iskoola Pota"/>
+        <a:font script="Mong" typeface="Mongolian Baiti"/>
+        <a:font script="Viet" typeface="Arial"/>
+        <a:font script="Uigh" typeface="Microsoft Uighur"/>
+        <a:font script="Geor" typeface="Sylfaen"/>
+        <a:font script="Armn" typeface="Arial"/>
+        <a:font script="Bugi" typeface="Leelawadee UI"/>
+        <a:font script="Bopo" typeface="Microsoft JhengHei"/>
+        <a:font script="Java" typeface="Javanese Text"/>
+        <a:font script="Lisu" typeface="Segoe UI"/>
+        <a:font script="Mymr" typeface="Myanmar Text"/>
+        <a:font script="Nkoo" typeface="Ebrima"/>
+        <a:font script="Olck" typeface="Nirmala UI"/>
+        <a:font script="Osma" typeface="Ebrima"/>
+        <a:font script="Phag" typeface="Phagspa"/>
+        <a:font script="Syrn" typeface="Estrangelo Edessa"/>
+        <a:font script="Syrj" typeface="Estrangelo Edessa"/>
+        <a:font script="Syre" typeface="Estrangelo Edessa"/>
+        <a:font script="Sora" typeface="Nirmala UI"/>
+        <a:font script="Tale" typeface="Microsoft Tai Le"/>
+        <a:font script="Talu" typeface="Microsoft New Tai Lue"/>
+        <a:font script="Tfng" typeface="Ebrima"/>
+      </a:minorFont>
+    </a:fontScheme>
+    <a:fmtScheme name="Office">
+      <a:fillStyleLst>
+        <a:solidFill>
+          <a:schemeClr val="phClr"/>
+        </a:solidFill>
+        <a:gradFill rotWithShape="1">
+          <a:gsLst>
+            <a:gs pos="0">
+              <a:schemeClr val="phClr">
+                <a:lumMod val="110000"/>
+                <a:satMod val="105000"/>
+                <a:tint val="67000"/>
+              </a:schemeClr>
+            </a:gs>
+            <a:gs pos="50000">
+              <a:schemeClr val="phClr">
+                <a:lumMod val="105000"/>
+                <a:satMod val="103000"/>
+                <a:tint val="73000"/>
+              </a:schemeClr>
+            </a:gs>
+            <a:gs pos="100000">
+              <a:schemeClr val="phClr">
+                <a:lumMod val="105000"/>
+                <a:satMod val="109000"/>
+                <a:tint val="81000"/>
+              </a:schemeClr>
+            </a:gs>
+          </a:gsLst>
+          <a:lin ang="5400000" scaled="0"/>
+        </a:gradFill>
+        <a:gradFill rotWithShape="1">
+          <a:gsLst>
+            <a:gs pos="0">
+              <a:schemeClr val="phClr">
+                <a:satMod val="103000"/>
+                <a:lumMod val="102000"/>
+                <a:tint val="94000"/>
+              </a:schemeClr>
+            </a:gs>
+            <a:gs pos="50000">
+              <a:schemeClr val="phClr">
+                <a:satMod val="110000"/>
+                <a:lumMod val="100000"/>
+                <a:shade val="100000"/>
+              </a:schemeClr>
+            </a:gs>
+            <a:gs pos="100000">
+              <a:schemeClr val="phClr">
+                <a:lumMod val="99000"/>
+                <a:satMod val="120000"/>
+                <a:shade val="78000"/>
+              </a:schemeClr>
+            </a:gs>
+          </a:gsLst>
+          <a:lin ang="5400000" scaled="0"/>
+        </a:gradFill>
+      </a:fillStyleLst>
+      <a:lnStyleLst>
+        <a:ln w="12700" cap="flat" cmpd="sng" algn="ctr">
+          <a:solidFill>
+            <a:schemeClr val="phClr"/>
+          </a:solidFill>
+          <a:prstDash val="solid"/>
+          <a:miter lim="800000"/>
+        </a:ln>
+        <a:ln w="19050" cap="flat" cmpd="sng" algn="ctr">
+          <a:solidFill>
+            <a:schemeClr val="phClr"/>
+          </a:solidFill>
+          <a:prstDash val="solid"/>
+          <a:miter lim="800000"/>
+        </a:ln>
+        <a:ln w="25400" cap="flat" cmpd="sng" algn="ctr">
+          <a:solidFill>
+            <a:schemeClr val="phClr"/>
+          </a:solidFill>
+          <a:prstDash val="solid"/>
+          <a:miter lim="800000"/>
+        </a:ln>
+      </a:lnStyleLst>
+      <a:effectStyleLst>
+        <a:effectStyle>
+          <a:effectLst/>
+        </a:effectStyle>
+        <a:effectStyle>
+          <a:effectLst/>
+        </a:effectStyle>
+        <a:effectStyle>
+          <a:effectLst>
+            <a:outerShdw blurRad="57150" dist="19050" dir="5400000" algn="ctr" rotWithShape="0">
+              <a:srgbClr val="000000">
+                <a:alpha val="63000"/>
+              </a:srgbClr>
+            </a:outerShdw>
+          </a:effectLst>
+        </a:effectStyle>
+      </a:effectStyleLst>
+      <a:bgFillStyleLst>
+        <a:solidFill>
+          <a:schemeClr val="phClr"/>
+        </a:solidFill>
+        <a:solidFill>
+          <a:schemeClr val="phClr">
+            <a:tint val="95000"/>
+            <a:satMod val="170000"/>
+          </a:schemeClr>
+        </a:solidFill>
+        <a:gradFill rotWithShape="1">
+          <a:gsLst>
+            <a:gs pos="0">
+              <a:schemeClr val="phClr">
+                <a:tint val="93000"/>
+                <a:satMod val="150000"/>
+                <a:shade val="98000"/>
+                <a:lumMod val="102000"/>
+              </a:schemeClr>
+            </a:gs>
+            <a:gs pos="50000">
+              <a:schemeClr val="phClr">
+                <a:tint val="98000"/>
+                <a:satMod val="130000"/>
+                <a:shade val="90000"/>
+                <a:lumMod val="103000"/>
+              </a:schemeClr>
+            </a:gs>
+            <a:gs pos="100000">
+              <a:schemeClr val="phClr">
+                <a:shade val="63000"/>
+                <a:satMod val="120000"/>
+              </a:schemeClr>
+            </a:gs>
+          </a:gsLst>
+          <a:lin ang="5400000" scaled="0"/>
+        </a:gradFill>
+      </a:bgFillStyleLst>
+    </a:fmtScheme>
+  </a:themeElements>
+  <a:objectDefaults>
+    <a:lnDef>
+      <a:spPr/>
+      <a:bodyPr/>
+      <a:lstStyle/>
+      <a:style>
+        <a:lnRef idx="2">
+          <a:schemeClr val="accent1"/>
+        </a:lnRef>
+        <a:fillRef idx="0">
+          <a:schemeClr val="accent1"/>
+        </a:fillRef>
+        <a:effectRef idx="1">
+          <a:schemeClr val="accent1"/>
+        </a:effectRef>
+        <a:fontRef idx="minor">
+          <a:schemeClr val="tx1"/>
+        </a:fontRef>
+      </a:style>
+    </a:lnDef>
+  </a:objectDefaults>
+  <a:extraClrSchemeLst/>
+  <a:extLst>
+    <a:ext uri="{05A4C25C-085E-4340-85A3-A5531E510DB2}">
+      <thm15:themeFamily xmlns:thm15="http://schemas.microsoft.com/office/thememl/2012/main" name="Office Theme" id="{2E142A2C-CD16-42D6-873A-C26D2A0506FA}" vid="{1BDDFF52-6CD6-40A5-AB3C-68EB2F1E4D0A}"/>
+    </a:ext>
+  </a:extLst>
+</a:theme>
 </file>
</xml_diff>